<commit_message>
Made small updates to the title page
</commit_message>
<xml_diff>
--- a/Agentic_Agile_Product_Development_by_Ari_Koinuma.pptx
+++ b/Agentic_Agile_Product_Development_by_Ari_Koinuma.pptx
@@ -838,7 +838,7 @@
   <p:cSld>
     <p:spTree>
       <p:nvGrpSpPr>
-        <p:cNvPr id="235" name="Shape 235"/>
+        <p:cNvPr id="236" name="Shape 236"/>
         <p:cNvGrpSpPr/>
         <p:nvPr/>
       </p:nvGrpSpPr>
@@ -852,7 +852,7 @@
       </p:grpSpPr>
       <p:sp>
         <p:nvSpPr>
-          <p:cNvPr id="236" name="Google Shape;236;g3f7727724e6_8_5:notes"/>
+          <p:cNvPr id="237" name="Google Shape;237;g3f7727724e6_8_5:notes"/>
           <p:cNvSpPr/>
           <p:nvPr>
             <p:ph idx="2" type="sldImg"/>
@@ -887,7 +887,7 @@
       </p:sp>
       <p:sp>
         <p:nvSpPr>
-          <p:cNvPr id="237" name="Google Shape;237;g3f7727724e6_8_5:notes"/>
+          <p:cNvPr id="238" name="Google Shape;238;g3f7727724e6_8_5:notes"/>
           <p:cNvSpPr txBox="1"/>
           <p:nvPr>
             <p:ph idx="1" type="body"/>
@@ -937,7 +937,7 @@
   <p:cSld>
     <p:spTree>
       <p:nvGrpSpPr>
-        <p:cNvPr id="245" name="Shape 245"/>
+        <p:cNvPr id="246" name="Shape 246"/>
         <p:cNvGrpSpPr/>
         <p:nvPr/>
       </p:nvGrpSpPr>
@@ -951,7 +951,7 @@
       </p:grpSpPr>
       <p:sp>
         <p:nvSpPr>
-          <p:cNvPr id="246" name="Google Shape;246;g3f7703a5743_0_250:notes"/>
+          <p:cNvPr id="247" name="Google Shape;247;g3f7703a5743_0_250:notes"/>
           <p:cNvSpPr/>
           <p:nvPr>
             <p:ph idx="2" type="sldImg"/>
@@ -986,7 +986,7 @@
       </p:sp>
       <p:sp>
         <p:nvSpPr>
-          <p:cNvPr id="247" name="Google Shape;247;g3f7703a5743_0_250:notes"/>
+          <p:cNvPr id="248" name="Google Shape;248;g3f7703a5743_0_250:notes"/>
           <p:cNvSpPr txBox="1"/>
           <p:nvPr>
             <p:ph idx="1" type="body"/>
@@ -1036,7 +1036,7 @@
   <p:cSld>
     <p:spTree>
       <p:nvGrpSpPr>
-        <p:cNvPr id="255" name="Shape 255"/>
+        <p:cNvPr id="256" name="Shape 256"/>
         <p:cNvGrpSpPr/>
         <p:nvPr/>
       </p:nvGrpSpPr>
@@ -1050,7 +1050,7 @@
       </p:grpSpPr>
       <p:sp>
         <p:nvSpPr>
-          <p:cNvPr id="256" name="Google Shape;256;g3f7703a5743_0_257:notes"/>
+          <p:cNvPr id="257" name="Google Shape;257;g3f7703a5743_0_257:notes"/>
           <p:cNvSpPr/>
           <p:nvPr>
             <p:ph idx="2" type="sldImg"/>
@@ -1085,7 +1085,7 @@
       </p:sp>
       <p:sp>
         <p:nvSpPr>
-          <p:cNvPr id="257" name="Google Shape;257;g3f7703a5743_0_257:notes"/>
+          <p:cNvPr id="258" name="Google Shape;258;g3f7703a5743_0_257:notes"/>
           <p:cNvSpPr txBox="1"/>
           <p:nvPr>
             <p:ph idx="1" type="body"/>
@@ -1135,7 +1135,7 @@
   <p:cSld>
     <p:spTree>
       <p:nvGrpSpPr>
-        <p:cNvPr id="265" name="Shape 265"/>
+        <p:cNvPr id="266" name="Shape 266"/>
         <p:cNvGrpSpPr/>
         <p:nvPr/>
       </p:nvGrpSpPr>
@@ -1149,7 +1149,7 @@
       </p:grpSpPr>
       <p:sp>
         <p:nvSpPr>
-          <p:cNvPr id="266" name="Google Shape;266;g3f7703a5743_0_264:notes"/>
+          <p:cNvPr id="267" name="Google Shape;267;g3f7703a5743_0_264:notes"/>
           <p:cNvSpPr/>
           <p:nvPr>
             <p:ph idx="2" type="sldImg"/>
@@ -1184,7 +1184,7 @@
       </p:sp>
       <p:sp>
         <p:nvSpPr>
-          <p:cNvPr id="267" name="Google Shape;267;g3f7703a5743_0_264:notes"/>
+          <p:cNvPr id="268" name="Google Shape;268;g3f7703a5743_0_264:notes"/>
           <p:cNvSpPr txBox="1"/>
           <p:nvPr>
             <p:ph idx="1" type="body"/>
@@ -1234,7 +1234,7 @@
   <p:cSld>
     <p:spTree>
       <p:nvGrpSpPr>
-        <p:cNvPr id="275" name="Shape 275"/>
+        <p:cNvPr id="276" name="Shape 276"/>
         <p:cNvGrpSpPr/>
         <p:nvPr/>
       </p:nvGrpSpPr>
@@ -1248,7 +1248,7 @@
       </p:grpSpPr>
       <p:sp>
         <p:nvSpPr>
-          <p:cNvPr id="276" name="Google Shape;276;gd251bb473_0_600:notes"/>
+          <p:cNvPr id="277" name="Google Shape;277;gd251bb473_0_600:notes"/>
           <p:cNvSpPr/>
           <p:nvPr>
             <p:ph idx="2" type="sldImg"/>
@@ -1283,7 +1283,7 @@
       </p:sp>
       <p:sp>
         <p:nvSpPr>
-          <p:cNvPr id="277" name="Google Shape;277;gd251bb473_0_600:notes"/>
+          <p:cNvPr id="278" name="Google Shape;278;gd251bb473_0_600:notes"/>
           <p:cNvSpPr txBox="1"/>
           <p:nvPr>
             <p:ph idx="1" type="body"/>
@@ -1333,7 +1333,7 @@
   <p:cSld>
     <p:spTree>
       <p:nvGrpSpPr>
-        <p:cNvPr id="93" name="Shape 93"/>
+        <p:cNvPr id="94" name="Shape 94"/>
         <p:cNvGrpSpPr/>
         <p:nvPr/>
       </p:nvGrpSpPr>
@@ -1347,7 +1347,7 @@
       </p:grpSpPr>
       <p:sp>
         <p:nvSpPr>
-          <p:cNvPr id="94" name="Google Shape;94;gcb9a0b074_2_0:notes"/>
+          <p:cNvPr id="95" name="Google Shape;95;gcb9a0b074_2_0:notes"/>
           <p:cNvSpPr/>
           <p:nvPr>
             <p:ph idx="2" type="sldImg"/>
@@ -1382,7 +1382,7 @@
       </p:sp>
       <p:sp>
         <p:nvSpPr>
-          <p:cNvPr id="95" name="Google Shape;95;gcb9a0b074_2_0:notes"/>
+          <p:cNvPr id="96" name="Google Shape;96;gcb9a0b074_2_0:notes"/>
           <p:cNvSpPr txBox="1"/>
           <p:nvPr>
             <p:ph idx="1" type="body"/>
@@ -1432,7 +1432,7 @@
   <p:cSld>
     <p:spTree>
       <p:nvGrpSpPr>
-        <p:cNvPr id="105" name="Shape 105"/>
+        <p:cNvPr id="106" name="Shape 106"/>
         <p:cNvGrpSpPr/>
         <p:nvPr/>
       </p:nvGrpSpPr>
@@ -1446,7 +1446,7 @@
       </p:grpSpPr>
       <p:sp>
         <p:nvSpPr>
-          <p:cNvPr id="106" name="Google Shape;106;gd5b15f0a3_5_26:notes"/>
+          <p:cNvPr id="107" name="Google Shape;107;gd5b15f0a3_5_26:notes"/>
           <p:cNvSpPr/>
           <p:nvPr>
             <p:ph idx="2" type="sldImg"/>
@@ -1481,7 +1481,7 @@
       </p:sp>
       <p:sp>
         <p:nvSpPr>
-          <p:cNvPr id="107" name="Google Shape;107;gd5b15f0a3_5_26:notes"/>
+          <p:cNvPr id="108" name="Google Shape;108;gd5b15f0a3_5_26:notes"/>
           <p:cNvSpPr txBox="1"/>
           <p:nvPr>
             <p:ph idx="1" type="body"/>
@@ -1531,7 +1531,7 @@
   <p:cSld>
     <p:spTree>
       <p:nvGrpSpPr>
-        <p:cNvPr id="175" name="Shape 175"/>
+        <p:cNvPr id="176" name="Shape 176"/>
         <p:cNvGrpSpPr/>
         <p:nvPr/>
       </p:nvGrpSpPr>
@@ -1545,7 +1545,7 @@
       </p:grpSpPr>
       <p:sp>
         <p:nvSpPr>
-          <p:cNvPr id="176" name="Google Shape;176;g723630543_3_0:notes"/>
+          <p:cNvPr id="177" name="Google Shape;177;g723630543_3_0:notes"/>
           <p:cNvSpPr/>
           <p:nvPr>
             <p:ph idx="2" type="sldImg"/>
@@ -1580,7 +1580,7 @@
       </p:sp>
       <p:sp>
         <p:nvSpPr>
-          <p:cNvPr id="177" name="Google Shape;177;g723630543_3_0:notes"/>
+          <p:cNvPr id="178" name="Google Shape;178;g723630543_3_0:notes"/>
           <p:cNvSpPr txBox="1"/>
           <p:nvPr>
             <p:ph idx="1" type="body"/>
@@ -1630,7 +1630,7 @@
   <p:cSld>
     <p:spTree>
       <p:nvGrpSpPr>
-        <p:cNvPr id="185" name="Shape 185"/>
+        <p:cNvPr id="186" name="Shape 186"/>
         <p:cNvGrpSpPr/>
         <p:nvPr/>
       </p:nvGrpSpPr>
@@ -1644,7 +1644,7 @@
       </p:grpSpPr>
       <p:sp>
         <p:nvSpPr>
-          <p:cNvPr id="186" name="Google Shape;186;g3f7703a5743_0_215:notes"/>
+          <p:cNvPr id="187" name="Google Shape;187;g3f7703a5743_0_215:notes"/>
           <p:cNvSpPr/>
           <p:nvPr>
             <p:ph idx="2" type="sldImg"/>
@@ -1679,7 +1679,7 @@
       </p:sp>
       <p:sp>
         <p:nvSpPr>
-          <p:cNvPr id="187" name="Google Shape;187;g3f7703a5743_0_215:notes"/>
+          <p:cNvPr id="188" name="Google Shape;188;g3f7703a5743_0_215:notes"/>
           <p:cNvSpPr txBox="1"/>
           <p:nvPr>
             <p:ph idx="1" type="body"/>
@@ -1729,7 +1729,7 @@
   <p:cSld>
     <p:spTree>
       <p:nvGrpSpPr>
-        <p:cNvPr id="195" name="Shape 195"/>
+        <p:cNvPr id="196" name="Shape 196"/>
         <p:cNvGrpSpPr/>
         <p:nvPr/>
       </p:nvGrpSpPr>
@@ -1743,7 +1743,7 @@
       </p:grpSpPr>
       <p:sp>
         <p:nvSpPr>
-          <p:cNvPr id="196" name="Google Shape;196;g3f7703a5743_0_222:notes"/>
+          <p:cNvPr id="197" name="Google Shape;197;g3f7703a5743_0_222:notes"/>
           <p:cNvSpPr/>
           <p:nvPr>
             <p:ph idx="2" type="sldImg"/>
@@ -1778,7 +1778,7 @@
       </p:sp>
       <p:sp>
         <p:nvSpPr>
-          <p:cNvPr id="197" name="Google Shape;197;g3f7703a5743_0_222:notes"/>
+          <p:cNvPr id="198" name="Google Shape;198;g3f7703a5743_0_222:notes"/>
           <p:cNvSpPr txBox="1"/>
           <p:nvPr>
             <p:ph idx="1" type="body"/>
@@ -1828,7 +1828,7 @@
   <p:cSld>
     <p:spTree>
       <p:nvGrpSpPr>
-        <p:cNvPr id="205" name="Shape 205"/>
+        <p:cNvPr id="206" name="Shape 206"/>
         <p:cNvGrpSpPr/>
         <p:nvPr/>
       </p:nvGrpSpPr>
@@ -1842,7 +1842,7 @@
       </p:grpSpPr>
       <p:sp>
         <p:nvSpPr>
-          <p:cNvPr id="206" name="Google Shape;206;g3f7703a5743_0_229:notes"/>
+          <p:cNvPr id="207" name="Google Shape;207;g3f7703a5743_0_229:notes"/>
           <p:cNvSpPr/>
           <p:nvPr>
             <p:ph idx="2" type="sldImg"/>
@@ -1877,7 +1877,7 @@
       </p:sp>
       <p:sp>
         <p:nvSpPr>
-          <p:cNvPr id="207" name="Google Shape;207;g3f7703a5743_0_229:notes"/>
+          <p:cNvPr id="208" name="Google Shape;208;g3f7703a5743_0_229:notes"/>
           <p:cNvSpPr txBox="1"/>
           <p:nvPr>
             <p:ph idx="1" type="body"/>
@@ -1927,7 +1927,7 @@
   <p:cSld>
     <p:spTree>
       <p:nvGrpSpPr>
-        <p:cNvPr id="215" name="Shape 215"/>
+        <p:cNvPr id="216" name="Shape 216"/>
         <p:cNvGrpSpPr/>
         <p:nvPr/>
       </p:nvGrpSpPr>
@@ -1941,7 +1941,7 @@
       </p:grpSpPr>
       <p:sp>
         <p:nvSpPr>
-          <p:cNvPr id="216" name="Google Shape;216;g3f7703a5743_0_236:notes"/>
+          <p:cNvPr id="217" name="Google Shape;217;g3f7703a5743_0_236:notes"/>
           <p:cNvSpPr/>
           <p:nvPr>
             <p:ph idx="2" type="sldImg"/>
@@ -1976,7 +1976,7 @@
       </p:sp>
       <p:sp>
         <p:nvSpPr>
-          <p:cNvPr id="217" name="Google Shape;217;g3f7703a5743_0_236:notes"/>
+          <p:cNvPr id="218" name="Google Shape;218;g3f7703a5743_0_236:notes"/>
           <p:cNvSpPr txBox="1"/>
           <p:nvPr>
             <p:ph idx="1" type="body"/>
@@ -2026,7 +2026,7 @@
   <p:cSld>
     <p:spTree>
       <p:nvGrpSpPr>
-        <p:cNvPr id="225" name="Shape 225"/>
+        <p:cNvPr id="226" name="Shape 226"/>
         <p:cNvGrpSpPr/>
         <p:nvPr/>
       </p:nvGrpSpPr>
@@ -2040,7 +2040,7 @@
       </p:grpSpPr>
       <p:sp>
         <p:nvSpPr>
-          <p:cNvPr id="226" name="Google Shape;226;g3f7703a5743_0_243:notes"/>
+          <p:cNvPr id="227" name="Google Shape;227;g3f7703a5743_0_243:notes"/>
           <p:cNvSpPr/>
           <p:nvPr>
             <p:ph idx="2" type="sldImg"/>
@@ -2075,7 +2075,7 @@
       </p:sp>
       <p:sp>
         <p:nvSpPr>
-          <p:cNvPr id="227" name="Google Shape;227;g3f7703a5743_0_243:notes"/>
+          <p:cNvPr id="228" name="Google Shape;228;g3f7703a5743_0_243:notes"/>
           <p:cNvSpPr txBox="1"/>
           <p:nvPr>
             <p:ph idx="1" type="body"/>
@@ -9408,6 +9408,64 @@
           </a:ln>
         </p:spPr>
       </p:pic>
+      <p:sp>
+        <p:nvSpPr>
+          <p:cNvPr id="93" name="Google Shape;93;p15"/>
+          <p:cNvSpPr txBox="1"/>
+          <p:nvPr/>
+        </p:nvSpPr>
+        <p:spPr>
+          <a:xfrm>
+            <a:off x="2108444" y="2034459"/>
+            <a:ext cx="6621300" cy="277500"/>
+          </a:xfrm>
+          <a:prstGeom prst="rect">
+            <a:avLst/>
+          </a:prstGeom>
+          <a:noFill/>
+          <a:ln>
+            <a:noFill/>
+          </a:ln>
+        </p:spPr>
+        <p:txBody>
+          <a:bodyPr anchorCtr="0" anchor="t" bIns="91425" lIns="91425" spcFirstLastPara="1" rIns="91425" wrap="square" tIns="91425">
+            <a:noAutofit/>
+          </a:bodyPr>
+          <a:lstStyle/>
+          <a:p>
+            <a:pPr indent="0" lvl="0" marL="0" rtl="0" algn="l">
+              <a:spcBef>
+                <a:spcPts val="0"/>
+              </a:spcBef>
+              <a:spcAft>
+                <a:spcPts val="0"/>
+              </a:spcAft>
+              <a:buNone/>
+            </a:pPr>
+            <a:r>
+              <a:rPr lang="en">
+                <a:solidFill>
+                  <a:schemeClr val="lt1"/>
+                </a:solidFill>
+                <a:latin typeface="Montserrat Medium"/>
+                <a:ea typeface="Montserrat Medium"/>
+                <a:cs typeface="Montserrat Medium"/>
+                <a:sym typeface="Montserrat Medium"/>
+              </a:rPr>
+              <a:t>How AI can facilitate effective Agile product development</a:t>
+            </a:r>
+            <a:endParaRPr>
+              <a:solidFill>
+                <a:schemeClr val="lt1"/>
+              </a:solidFill>
+              <a:latin typeface="Montserrat Medium"/>
+              <a:ea typeface="Montserrat Medium"/>
+              <a:cs typeface="Montserrat Medium"/>
+              <a:sym typeface="Montserrat Medium"/>
+            </a:endParaRPr>
+          </a:p>
+        </p:txBody>
+      </p:sp>
     </p:spTree>
   </p:cSld>
   <p:clrMapOvr>
@@ -9428,7 +9486,7 @@
     </p:bg>
     <p:spTree>
       <p:nvGrpSpPr>
-        <p:cNvPr id="238" name="Shape 238"/>
+        <p:cNvPr id="239" name="Shape 239"/>
         <p:cNvGrpSpPr/>
         <p:nvPr/>
       </p:nvGrpSpPr>
@@ -9440,34 +9498,6 @@
           <a:chExt cx="0" cy="0"/>
         </a:xfrm>
       </p:grpSpPr>
-      <p:pic>
-        <p:nvPicPr>
-          <p:cNvPr id="239" name="Google Shape;239;p24"/>
-          <p:cNvPicPr preferRelativeResize="0"/>
-          <p:nvPr/>
-        </p:nvPicPr>
-        <p:blipFill>
-          <a:blip r:embed="rId3">
-            <a:alphaModFix amt="50000"/>
-          </a:blip>
-          <a:stretch>
-            <a:fillRect/>
-          </a:stretch>
-        </p:blipFill>
-        <p:spPr>
-          <a:xfrm>
-            <a:off x="4966625" y="982486"/>
-            <a:ext cx="3178525" cy="3178525"/>
-          </a:xfrm>
-          <a:prstGeom prst="rect">
-            <a:avLst/>
-          </a:prstGeom>
-          <a:noFill/>
-          <a:ln>
-            <a:noFill/>
-          </a:ln>
-        </p:spPr>
-      </p:pic>
       <p:pic>
         <p:nvPicPr>
           <p:cNvPr id="240" name="Google Shape;240;p24"/>
@@ -9484,7 +9514,7 @@
         </p:blipFill>
         <p:spPr>
           <a:xfrm>
-            <a:off x="1030225" y="982486"/>
+            <a:off x="4966625" y="982486"/>
             <a:ext cx="3178525" cy="3178525"/>
           </a:xfrm>
           <a:prstGeom prst="rect">
@@ -9499,6 +9529,34 @@
       <p:pic>
         <p:nvPicPr>
           <p:cNvPr id="241" name="Google Shape;241;p24"/>
+          <p:cNvPicPr preferRelativeResize="0"/>
+          <p:nvPr/>
+        </p:nvPicPr>
+        <p:blipFill>
+          <a:blip r:embed="rId3">
+            <a:alphaModFix amt="50000"/>
+          </a:blip>
+          <a:stretch>
+            <a:fillRect/>
+          </a:stretch>
+        </p:blipFill>
+        <p:spPr>
+          <a:xfrm>
+            <a:off x="1030225" y="982486"/>
+            <a:ext cx="3178525" cy="3178525"/>
+          </a:xfrm>
+          <a:prstGeom prst="rect">
+            <a:avLst/>
+          </a:prstGeom>
+          <a:noFill/>
+          <a:ln>
+            <a:noFill/>
+          </a:ln>
+        </p:spPr>
+      </p:pic>
+      <p:pic>
+        <p:nvPicPr>
+          <p:cNvPr id="242" name="Google Shape;242;p24"/>
           <p:cNvPicPr preferRelativeResize="0"/>
           <p:nvPr/>
         </p:nvPicPr>
@@ -9526,7 +9584,7 @@
       </p:pic>
       <p:sp>
         <p:nvSpPr>
-          <p:cNvPr id="242" name="Google Shape;242;p24"/>
+          <p:cNvPr id="243" name="Google Shape;243;p24"/>
           <p:cNvSpPr txBox="1"/>
           <p:nvPr/>
         </p:nvSpPr>
@@ -9584,7 +9642,7 @@
       </p:sp>
       <p:sp>
         <p:nvSpPr>
-          <p:cNvPr id="243" name="Google Shape;243;p24"/>
+          <p:cNvPr id="244" name="Google Shape;244;p24"/>
           <p:cNvSpPr txBox="1"/>
           <p:nvPr>
             <p:ph idx="4294967295" type="body"/>
@@ -9726,7 +9784,7 @@
       </p:sp>
       <p:pic>
         <p:nvPicPr>
-          <p:cNvPr id="244" name="Google Shape;244;p24"/>
+          <p:cNvPr id="245" name="Google Shape;245;p24"/>
           <p:cNvPicPr preferRelativeResize="0"/>
           <p:nvPr/>
         </p:nvPicPr>
@@ -9772,7 +9830,7 @@
     </p:bg>
     <p:spTree>
       <p:nvGrpSpPr>
-        <p:cNvPr id="248" name="Shape 248"/>
+        <p:cNvPr id="249" name="Shape 249"/>
         <p:cNvGrpSpPr/>
         <p:nvPr/>
       </p:nvGrpSpPr>
@@ -9784,34 +9842,6 @@
           <a:chExt cx="0" cy="0"/>
         </a:xfrm>
       </p:grpSpPr>
-      <p:pic>
-        <p:nvPicPr>
-          <p:cNvPr id="249" name="Google Shape;249;p25"/>
-          <p:cNvPicPr preferRelativeResize="0"/>
-          <p:nvPr/>
-        </p:nvPicPr>
-        <p:blipFill>
-          <a:blip r:embed="rId3">
-            <a:alphaModFix amt="50000"/>
-          </a:blip>
-          <a:stretch>
-            <a:fillRect/>
-          </a:stretch>
-        </p:blipFill>
-        <p:spPr>
-          <a:xfrm>
-            <a:off x="4780800" y="794638"/>
-            <a:ext cx="3554225" cy="3554225"/>
-          </a:xfrm>
-          <a:prstGeom prst="rect">
-            <a:avLst/>
-          </a:prstGeom>
-          <a:noFill/>
-          <a:ln>
-            <a:noFill/>
-          </a:ln>
-        </p:spPr>
-      </p:pic>
       <p:pic>
         <p:nvPicPr>
           <p:cNvPr id="250" name="Google Shape;250;p25"/>
@@ -9828,7 +9858,7 @@
         </p:blipFill>
         <p:spPr>
           <a:xfrm>
-            <a:off x="825798" y="794638"/>
+            <a:off x="4780800" y="794638"/>
             <a:ext cx="3554225" cy="3554225"/>
           </a:xfrm>
           <a:prstGeom prst="rect">
@@ -9843,6 +9873,34 @@
       <p:pic>
         <p:nvPicPr>
           <p:cNvPr id="251" name="Google Shape;251;p25"/>
+          <p:cNvPicPr preferRelativeResize="0"/>
+          <p:nvPr/>
+        </p:nvPicPr>
+        <p:blipFill>
+          <a:blip r:embed="rId3">
+            <a:alphaModFix amt="50000"/>
+          </a:blip>
+          <a:stretch>
+            <a:fillRect/>
+          </a:stretch>
+        </p:blipFill>
+        <p:spPr>
+          <a:xfrm>
+            <a:off x="825798" y="794638"/>
+            <a:ext cx="3554225" cy="3554225"/>
+          </a:xfrm>
+          <a:prstGeom prst="rect">
+            <a:avLst/>
+          </a:prstGeom>
+          <a:noFill/>
+          <a:ln>
+            <a:noFill/>
+          </a:ln>
+        </p:spPr>
+      </p:pic>
+      <p:pic>
+        <p:nvPicPr>
+          <p:cNvPr id="252" name="Google Shape;252;p25"/>
           <p:cNvPicPr preferRelativeResize="0"/>
           <p:nvPr/>
         </p:nvPicPr>
@@ -9870,7 +9928,7 @@
       </p:pic>
       <p:sp>
         <p:nvSpPr>
-          <p:cNvPr id="252" name="Google Shape;252;p25"/>
+          <p:cNvPr id="253" name="Google Shape;253;p25"/>
           <p:cNvSpPr txBox="1"/>
           <p:nvPr/>
         </p:nvSpPr>
@@ -9928,7 +9986,7 @@
       </p:sp>
       <p:sp>
         <p:nvSpPr>
-          <p:cNvPr id="253" name="Google Shape;253;p25"/>
+          <p:cNvPr id="254" name="Google Shape;254;p25"/>
           <p:cNvSpPr txBox="1"/>
           <p:nvPr>
             <p:ph idx="4294967295" type="body"/>
@@ -10070,7 +10128,7 @@
       </p:sp>
       <p:pic>
         <p:nvPicPr>
-          <p:cNvPr id="254" name="Google Shape;254;p25"/>
+          <p:cNvPr id="255" name="Google Shape;255;p25"/>
           <p:cNvPicPr preferRelativeResize="0"/>
           <p:nvPr/>
         </p:nvPicPr>
@@ -10116,7 +10174,7 @@
     </p:bg>
     <p:spTree>
       <p:nvGrpSpPr>
-        <p:cNvPr id="258" name="Shape 258"/>
+        <p:cNvPr id="259" name="Shape 259"/>
         <p:cNvGrpSpPr/>
         <p:nvPr/>
       </p:nvGrpSpPr>
@@ -10128,34 +10186,6 @@
           <a:chExt cx="0" cy="0"/>
         </a:xfrm>
       </p:grpSpPr>
-      <p:pic>
-        <p:nvPicPr>
-          <p:cNvPr id="259" name="Google Shape;259;p26"/>
-          <p:cNvPicPr preferRelativeResize="0"/>
-          <p:nvPr/>
-        </p:nvPicPr>
-        <p:blipFill>
-          <a:blip r:embed="rId3">
-            <a:alphaModFix amt="50000"/>
-          </a:blip>
-          <a:stretch>
-            <a:fillRect/>
-          </a:stretch>
-        </p:blipFill>
-        <p:spPr>
-          <a:xfrm>
-            <a:off x="4913882" y="953354"/>
-            <a:ext cx="3236800" cy="3236800"/>
-          </a:xfrm>
-          <a:prstGeom prst="rect">
-            <a:avLst/>
-          </a:prstGeom>
-          <a:noFill/>
-          <a:ln>
-            <a:noFill/>
-          </a:ln>
-        </p:spPr>
-      </p:pic>
       <p:pic>
         <p:nvPicPr>
           <p:cNvPr id="260" name="Google Shape;260;p26"/>
@@ -10172,7 +10202,7 @@
         </p:blipFill>
         <p:spPr>
           <a:xfrm>
-            <a:off x="967500" y="953354"/>
+            <a:off x="4913882" y="953354"/>
             <a:ext cx="3236800" cy="3236800"/>
           </a:xfrm>
           <a:prstGeom prst="rect">
@@ -10187,6 +10217,34 @@
       <p:pic>
         <p:nvPicPr>
           <p:cNvPr id="261" name="Google Shape;261;p26"/>
+          <p:cNvPicPr preferRelativeResize="0"/>
+          <p:nvPr/>
+        </p:nvPicPr>
+        <p:blipFill>
+          <a:blip r:embed="rId3">
+            <a:alphaModFix amt="50000"/>
+          </a:blip>
+          <a:stretch>
+            <a:fillRect/>
+          </a:stretch>
+        </p:blipFill>
+        <p:spPr>
+          <a:xfrm>
+            <a:off x="967500" y="953354"/>
+            <a:ext cx="3236800" cy="3236800"/>
+          </a:xfrm>
+          <a:prstGeom prst="rect">
+            <a:avLst/>
+          </a:prstGeom>
+          <a:noFill/>
+          <a:ln>
+            <a:noFill/>
+          </a:ln>
+        </p:spPr>
+      </p:pic>
+      <p:pic>
+        <p:nvPicPr>
+          <p:cNvPr id="262" name="Google Shape;262;p26"/>
           <p:cNvPicPr preferRelativeResize="0"/>
           <p:nvPr/>
         </p:nvPicPr>
@@ -10214,7 +10272,7 @@
       </p:pic>
       <p:sp>
         <p:nvSpPr>
-          <p:cNvPr id="262" name="Google Shape;262;p26"/>
+          <p:cNvPr id="263" name="Google Shape;263;p26"/>
           <p:cNvSpPr txBox="1"/>
           <p:nvPr/>
         </p:nvSpPr>
@@ -10272,7 +10330,7 @@
       </p:sp>
       <p:sp>
         <p:nvSpPr>
-          <p:cNvPr id="263" name="Google Shape;263;p26"/>
+          <p:cNvPr id="264" name="Google Shape;264;p26"/>
           <p:cNvSpPr txBox="1"/>
           <p:nvPr>
             <p:ph idx="4294967295" type="body"/>
@@ -10405,7 +10463,7 @@
       </p:sp>
       <p:pic>
         <p:nvPicPr>
-          <p:cNvPr id="264" name="Google Shape;264;p26"/>
+          <p:cNvPr id="265" name="Google Shape;265;p26"/>
           <p:cNvPicPr preferRelativeResize="0"/>
           <p:nvPr/>
         </p:nvPicPr>
@@ -10451,7 +10509,7 @@
     </p:bg>
     <p:spTree>
       <p:nvGrpSpPr>
-        <p:cNvPr id="268" name="Shape 268"/>
+        <p:cNvPr id="269" name="Shape 269"/>
         <p:cNvGrpSpPr/>
         <p:nvPr/>
       </p:nvGrpSpPr>
@@ -10463,34 +10521,6 @@
           <a:chExt cx="0" cy="0"/>
         </a:xfrm>
       </p:grpSpPr>
-      <p:pic>
-        <p:nvPicPr>
-          <p:cNvPr id="269" name="Google Shape;269;p27"/>
-          <p:cNvPicPr preferRelativeResize="0"/>
-          <p:nvPr/>
-        </p:nvPicPr>
-        <p:blipFill>
-          <a:blip r:embed="rId3">
-            <a:alphaModFix amt="50000"/>
-          </a:blip>
-          <a:stretch>
-            <a:fillRect/>
-          </a:stretch>
-        </p:blipFill>
-        <p:spPr>
-          <a:xfrm>
-            <a:off x="4785311" y="802475"/>
-            <a:ext cx="3538550" cy="3538550"/>
-          </a:xfrm>
-          <a:prstGeom prst="rect">
-            <a:avLst/>
-          </a:prstGeom>
-          <a:noFill/>
-          <a:ln>
-            <a:noFill/>
-          </a:ln>
-        </p:spPr>
-      </p:pic>
       <p:pic>
         <p:nvPicPr>
           <p:cNvPr id="270" name="Google Shape;270;p27"/>
@@ -10507,7 +10537,7 @@
         </p:blipFill>
         <p:spPr>
           <a:xfrm>
-            <a:off x="829168" y="802475"/>
+            <a:off x="4785311" y="802475"/>
             <a:ext cx="3538550" cy="3538550"/>
           </a:xfrm>
           <a:prstGeom prst="rect">
@@ -10522,6 +10552,34 @@
       <p:pic>
         <p:nvPicPr>
           <p:cNvPr id="271" name="Google Shape;271;p27"/>
+          <p:cNvPicPr preferRelativeResize="0"/>
+          <p:nvPr/>
+        </p:nvPicPr>
+        <p:blipFill>
+          <a:blip r:embed="rId3">
+            <a:alphaModFix amt="50000"/>
+          </a:blip>
+          <a:stretch>
+            <a:fillRect/>
+          </a:stretch>
+        </p:blipFill>
+        <p:spPr>
+          <a:xfrm>
+            <a:off x="829168" y="802475"/>
+            <a:ext cx="3538550" cy="3538550"/>
+          </a:xfrm>
+          <a:prstGeom prst="rect">
+            <a:avLst/>
+          </a:prstGeom>
+          <a:noFill/>
+          <a:ln>
+            <a:noFill/>
+          </a:ln>
+        </p:spPr>
+      </p:pic>
+      <p:pic>
+        <p:nvPicPr>
+          <p:cNvPr id="272" name="Google Shape;272;p27"/>
           <p:cNvPicPr preferRelativeResize="0"/>
           <p:nvPr/>
         </p:nvPicPr>
@@ -10549,7 +10607,7 @@
       </p:pic>
       <p:sp>
         <p:nvSpPr>
-          <p:cNvPr id="272" name="Google Shape;272;p27"/>
+          <p:cNvPr id="273" name="Google Shape;273;p27"/>
           <p:cNvSpPr txBox="1"/>
           <p:nvPr/>
         </p:nvSpPr>
@@ -10607,7 +10665,7 @@
       </p:sp>
       <p:sp>
         <p:nvSpPr>
-          <p:cNvPr id="273" name="Google Shape;273;p27"/>
+          <p:cNvPr id="274" name="Google Shape;274;p27"/>
           <p:cNvSpPr txBox="1"/>
           <p:nvPr>
             <p:ph idx="4294967295" type="body"/>
@@ -10749,7 +10807,7 @@
       </p:sp>
       <p:pic>
         <p:nvPicPr>
-          <p:cNvPr id="274" name="Google Shape;274;p27"/>
+          <p:cNvPr id="275" name="Google Shape;275;p27"/>
           <p:cNvPicPr preferRelativeResize="0"/>
           <p:nvPr/>
         </p:nvPicPr>
@@ -10788,7 +10846,7 @@
   <p:cSld>
     <p:spTree>
       <p:nvGrpSpPr>
-        <p:cNvPr id="278" name="Shape 278"/>
+        <p:cNvPr id="279" name="Shape 279"/>
         <p:cNvGrpSpPr/>
         <p:nvPr/>
       </p:nvGrpSpPr>
@@ -10802,7 +10860,7 @@
       </p:grpSpPr>
       <p:sp>
         <p:nvSpPr>
-          <p:cNvPr id="279" name="Google Shape;279;p28"/>
+          <p:cNvPr id="280" name="Google Shape;280;p28"/>
           <p:cNvSpPr txBox="1"/>
           <p:nvPr>
             <p:ph type="title"/>
@@ -10916,7 +10974,7 @@
       </p:sp>
       <p:grpSp>
         <p:nvGrpSpPr>
-          <p:cNvPr id="280" name="Google Shape;280;p28"/>
+          <p:cNvPr id="281" name="Google Shape;281;p28"/>
           <p:cNvGrpSpPr/>
           <p:nvPr/>
         </p:nvGrpSpPr>
@@ -10930,7 +10988,7 @@
         </p:grpSpPr>
         <p:pic>
           <p:nvPicPr>
-            <p:cNvPr id="281" name="Google Shape;281;p28"/>
+            <p:cNvPr id="282" name="Google Shape;282;p28"/>
             <p:cNvPicPr preferRelativeResize="0"/>
             <p:nvPr/>
           </p:nvPicPr>
@@ -10958,7 +11016,7 @@
         </p:pic>
         <p:sp>
           <p:nvSpPr>
-            <p:cNvPr id="282" name="Google Shape;282;p28"/>
+            <p:cNvPr id="283" name="Google Shape;283;p28"/>
             <p:cNvSpPr txBox="1"/>
             <p:nvPr/>
           </p:nvSpPr>
@@ -11086,7 +11144,7 @@
       </p:grpSp>
       <p:sp>
         <p:nvSpPr>
-          <p:cNvPr id="283" name="Google Shape;283;p28"/>
+          <p:cNvPr id="284" name="Google Shape;284;p28"/>
           <p:cNvSpPr txBox="1"/>
           <p:nvPr/>
         </p:nvSpPr>
@@ -11147,7 +11205,7 @@
   <p:cSld>
     <p:spTree>
       <p:nvGrpSpPr>
-        <p:cNvPr id="96" name="Shape 96"/>
+        <p:cNvPr id="97" name="Shape 97"/>
         <p:cNvGrpSpPr/>
         <p:nvPr/>
       </p:nvGrpSpPr>
@@ -11161,7 +11219,7 @@
       </p:grpSpPr>
       <p:sp>
         <p:nvSpPr>
-          <p:cNvPr id="97" name="Google Shape;97;p16"/>
+          <p:cNvPr id="98" name="Google Shape;98;p16"/>
           <p:cNvSpPr txBox="1"/>
           <p:nvPr>
             <p:ph type="title"/>
@@ -11243,7 +11301,7 @@
       </p:sp>
       <p:sp>
         <p:nvSpPr>
-          <p:cNvPr id="98" name="Google Shape;98;p16"/>
+          <p:cNvPr id="99" name="Google Shape;99;p16"/>
           <p:cNvSpPr/>
           <p:nvPr/>
         </p:nvSpPr>
@@ -11260,52 +11318,6 @@
           </a:prstGeom>
           <a:solidFill>
             <a:schemeClr val="accent2"/>
-          </a:solidFill>
-          <a:ln>
-            <a:noFill/>
-          </a:ln>
-        </p:spPr>
-        <p:txBody>
-          <a:bodyPr anchorCtr="0" anchor="ctr" bIns="91425" lIns="91425" spcFirstLastPara="1" rIns="91425" wrap="square" tIns="91425">
-            <a:noAutofit/>
-          </a:bodyPr>
-          <a:lstStyle/>
-          <a:p>
-            <a:pPr indent="0" lvl="0" marL="0" rtl="0" algn="l">
-              <a:spcBef>
-                <a:spcPts val="0"/>
-              </a:spcBef>
-              <a:spcAft>
-                <a:spcPts val="0"/>
-              </a:spcAft>
-              <a:buNone/>
-            </a:pPr>
-            <a:r>
-              <a:t/>
-            </a:r>
-            <a:endParaRPr/>
-          </a:p>
-        </p:txBody>
-      </p:sp>
-      <p:sp>
-        <p:nvSpPr>
-          <p:cNvPr id="99" name="Google Shape;99;p16"/>
-          <p:cNvSpPr/>
-          <p:nvPr/>
-        </p:nvSpPr>
-        <p:spPr>
-          <a:xfrm>
-            <a:off x="3210432" y="1696549"/>
-            <a:ext cx="2629500" cy="2244900"/>
-          </a:xfrm>
-          <a:prstGeom prst="wedgeRectCallout">
-            <a:avLst>
-              <a:gd fmla="val -20833" name="adj1"/>
-              <a:gd fmla="val 62500" name="adj2"/>
-            </a:avLst>
-          </a:prstGeom>
-          <a:solidFill>
-            <a:schemeClr val="accent5"/>
           </a:solidFill>
           <a:ln>
             <a:noFill/>
@@ -11341,7 +11353,7 @@
         </p:nvSpPr>
         <p:spPr>
           <a:xfrm>
-            <a:off x="6049089" y="1696549"/>
+            <a:off x="3210432" y="1696549"/>
             <a:ext cx="2629500" cy="2244900"/>
           </a:xfrm>
           <a:prstGeom prst="wedgeRectCallout">
@@ -11351,7 +11363,7 @@
             </a:avLst>
           </a:prstGeom>
           <a:solidFill>
-            <a:schemeClr val="dk1"/>
+            <a:schemeClr val="accent5"/>
           </a:solidFill>
           <a:ln>
             <a:noFill/>
@@ -11382,6 +11394,52 @@
       <p:sp>
         <p:nvSpPr>
           <p:cNvPr id="101" name="Google Shape;101;p16"/>
+          <p:cNvSpPr/>
+          <p:nvPr/>
+        </p:nvSpPr>
+        <p:spPr>
+          <a:xfrm>
+            <a:off x="6049089" y="1696549"/>
+            <a:ext cx="2629500" cy="2244900"/>
+          </a:xfrm>
+          <a:prstGeom prst="wedgeRectCallout">
+            <a:avLst>
+              <a:gd fmla="val -20833" name="adj1"/>
+              <a:gd fmla="val 62500" name="adj2"/>
+            </a:avLst>
+          </a:prstGeom>
+          <a:solidFill>
+            <a:schemeClr val="dk1"/>
+          </a:solidFill>
+          <a:ln>
+            <a:noFill/>
+          </a:ln>
+        </p:spPr>
+        <p:txBody>
+          <a:bodyPr anchorCtr="0" anchor="ctr" bIns="91425" lIns="91425" spcFirstLastPara="1" rIns="91425" wrap="square" tIns="91425">
+            <a:noAutofit/>
+          </a:bodyPr>
+          <a:lstStyle/>
+          <a:p>
+            <a:pPr indent="0" lvl="0" marL="0" rtl="0" algn="l">
+              <a:spcBef>
+                <a:spcPts val="0"/>
+              </a:spcBef>
+              <a:spcAft>
+                <a:spcPts val="0"/>
+              </a:spcAft>
+              <a:buNone/>
+            </a:pPr>
+            <a:r>
+              <a:t/>
+            </a:r>
+            <a:endParaRPr/>
+          </a:p>
+        </p:txBody>
+      </p:sp>
+      <p:sp>
+        <p:nvSpPr>
+          <p:cNvPr id="102" name="Google Shape;102;p16"/>
           <p:cNvSpPr txBox="1"/>
           <p:nvPr>
             <p:ph type="title"/>
@@ -11469,7 +11527,7 @@
       </p:sp>
       <p:sp>
         <p:nvSpPr>
-          <p:cNvPr id="102" name="Google Shape;102;p16"/>
+          <p:cNvPr id="103" name="Google Shape;103;p16"/>
           <p:cNvSpPr txBox="1"/>
           <p:nvPr>
             <p:ph type="title"/>
@@ -11574,7 +11632,7 @@
       </p:sp>
       <p:sp>
         <p:nvSpPr>
-          <p:cNvPr id="103" name="Google Shape;103;p16"/>
+          <p:cNvPr id="104" name="Google Shape;104;p16"/>
           <p:cNvSpPr txBox="1"/>
           <p:nvPr>
             <p:ph type="title"/>
@@ -11676,7 +11734,7 @@
       </p:sp>
       <p:sp>
         <p:nvSpPr>
-          <p:cNvPr id="104" name="Google Shape;104;p16"/>
+          <p:cNvPr id="105" name="Google Shape;105;p16"/>
           <p:cNvSpPr txBox="1"/>
           <p:nvPr/>
         </p:nvSpPr>
@@ -11752,7 +11810,7 @@
     </p:bg>
     <p:spTree>
       <p:nvGrpSpPr>
-        <p:cNvPr id="108" name="Shape 108"/>
+        <p:cNvPr id="109" name="Shape 109"/>
         <p:cNvGrpSpPr/>
         <p:nvPr/>
       </p:nvGrpSpPr>
@@ -11766,7 +11824,7 @@
       </p:grpSpPr>
       <p:sp>
         <p:nvSpPr>
-          <p:cNvPr id="109" name="Google Shape;109;p17"/>
+          <p:cNvPr id="110" name="Google Shape;110;p17"/>
           <p:cNvSpPr txBox="1"/>
           <p:nvPr>
             <p:ph idx="4294967295" type="title"/>
@@ -11819,7 +11877,7 @@
       </p:sp>
       <p:sp>
         <p:nvSpPr>
-          <p:cNvPr id="110" name="Google Shape;110;p17"/>
+          <p:cNvPr id="111" name="Google Shape;111;p17"/>
           <p:cNvSpPr/>
           <p:nvPr/>
         </p:nvSpPr>
@@ -11835,59 +11893,6 @@
           </a:prstGeom>
           <a:solidFill>
             <a:srgbClr val="055381"/>
-          </a:solidFill>
-          <a:ln>
-            <a:noFill/>
-          </a:ln>
-        </p:spPr>
-        <p:txBody>
-          <a:bodyPr anchorCtr="0" anchor="ctr" bIns="91425" lIns="91425" spcFirstLastPara="1" rIns="91425" wrap="square" tIns="91425">
-            <a:noAutofit/>
-          </a:bodyPr>
-          <a:lstStyle/>
-          <a:p>
-            <a:pPr indent="0" lvl="0" marL="0" rtl="0" algn="ctr">
-              <a:spcBef>
-                <a:spcPts val="0"/>
-              </a:spcBef>
-              <a:spcAft>
-                <a:spcPts val="0"/>
-              </a:spcAft>
-              <a:buNone/>
-            </a:pPr>
-            <a:r>
-              <a:t/>
-            </a:r>
-            <a:endParaRPr sz="1000">
-              <a:solidFill>
-                <a:schemeClr val="lt1"/>
-              </a:solidFill>
-              <a:latin typeface="Montserrat ExtraBold"/>
-              <a:ea typeface="Montserrat ExtraBold"/>
-              <a:cs typeface="Montserrat ExtraBold"/>
-              <a:sym typeface="Montserrat ExtraBold"/>
-            </a:endParaRPr>
-          </a:p>
-        </p:txBody>
-      </p:sp>
-      <p:sp>
-        <p:nvSpPr>
-          <p:cNvPr id="111" name="Google Shape;111;p17"/>
-          <p:cNvSpPr/>
-          <p:nvPr/>
-        </p:nvSpPr>
-        <p:spPr>
-          <a:xfrm>
-            <a:off x="3072962" y="2339147"/>
-            <a:ext cx="1412400" cy="550800"/>
-          </a:xfrm>
-          <a:prstGeom prst="roundRect">
-            <a:avLst>
-              <a:gd fmla="val 16667" name="adj"/>
-            </a:avLst>
-          </a:prstGeom>
-          <a:solidFill>
-            <a:srgbClr val="1155CC"/>
           </a:solidFill>
           <a:ln>
             <a:noFill/>
@@ -11931,7 +11936,7 @@
         </p:nvSpPr>
         <p:spPr>
           <a:xfrm>
-            <a:off x="1660555" y="1778397"/>
+            <a:off x="3072962" y="2339147"/>
             <a:ext cx="1412400" cy="550800"/>
           </a:xfrm>
           <a:prstGeom prst="roundRect">
@@ -11940,7 +11945,7 @@
             </a:avLst>
           </a:prstGeom>
           <a:solidFill>
-            <a:srgbClr val="35B0E1"/>
+            <a:srgbClr val="1155CC"/>
           </a:solidFill>
           <a:ln>
             <a:noFill/>
@@ -11984,7 +11989,7 @@
         </p:nvSpPr>
         <p:spPr>
           <a:xfrm>
-            <a:off x="250733" y="1227600"/>
+            <a:off x="1660555" y="1778397"/>
             <a:ext cx="1412400" cy="550800"/>
           </a:xfrm>
           <a:prstGeom prst="roundRect">
@@ -11993,7 +11998,7 @@
             </a:avLst>
           </a:prstGeom>
           <a:solidFill>
-            <a:schemeClr val="accent2"/>
+            <a:srgbClr val="35B0E1"/>
           </a:solidFill>
           <a:ln>
             <a:noFill/>
@@ -12037,8 +12042,8 @@
         </p:nvSpPr>
         <p:spPr>
           <a:xfrm>
-            <a:off x="250718" y="3901100"/>
-            <a:ext cx="1253400" cy="550800"/>
+            <a:off x="250733" y="1227600"/>
+            <a:ext cx="1412400" cy="550800"/>
           </a:xfrm>
           <a:prstGeom prst="roundRect">
             <a:avLst>
@@ -12046,14 +12051,14 @@
             </a:avLst>
           </a:prstGeom>
           <a:solidFill>
-            <a:srgbClr val="E44856"/>
+            <a:schemeClr val="accent2"/>
           </a:solidFill>
           <a:ln>
             <a:noFill/>
           </a:ln>
         </p:spPr>
         <p:txBody>
-          <a:bodyPr anchorCtr="0" anchor="ctr" bIns="91400" lIns="91400" spcFirstLastPara="1" rIns="91400" wrap="square" tIns="91400">
+          <a:bodyPr anchorCtr="0" anchor="ctr" bIns="91425" lIns="91425" spcFirstLastPara="1" rIns="91425" wrap="square" tIns="91425">
             <a:noAutofit/>
           </a:bodyPr>
           <a:lstStyle/>
@@ -12070,9 +12075,9 @@
             <a:r>
               <a:t/>
             </a:r>
-            <a:endParaRPr i="0" sz="1000">
+            <a:endParaRPr sz="1000">
               <a:solidFill>
-                <a:srgbClr val="FFFFFF"/>
+                <a:schemeClr val="lt1"/>
               </a:solidFill>
               <a:latin typeface="Montserrat ExtraBold"/>
               <a:ea typeface="Montserrat ExtraBold"/>
@@ -12090,7 +12095,7 @@
         </p:nvSpPr>
         <p:spPr>
           <a:xfrm>
-            <a:off x="3343598" y="3900200"/>
+            <a:off x="250718" y="3901100"/>
             <a:ext cx="1253400" cy="550800"/>
           </a:xfrm>
           <a:prstGeom prst="roundRect">
@@ -12099,7 +12104,7 @@
             </a:avLst>
           </a:prstGeom>
           <a:solidFill>
-            <a:srgbClr val="F58E31"/>
+            <a:srgbClr val="E44856"/>
           </a:solidFill>
           <a:ln>
             <a:noFill/>
@@ -12143,7 +12148,7 @@
         </p:nvSpPr>
         <p:spPr>
           <a:xfrm>
-            <a:off x="4908315" y="3898650"/>
+            <a:off x="3343598" y="3900200"/>
             <a:ext cx="1253400" cy="550800"/>
           </a:xfrm>
           <a:prstGeom prst="roundRect">
@@ -12152,7 +12157,7 @@
             </a:avLst>
           </a:prstGeom>
           <a:solidFill>
-            <a:srgbClr val="FFAE88"/>
+            <a:srgbClr val="F58E31"/>
           </a:solidFill>
           <a:ln>
             <a:noFill/>
@@ -12196,6 +12201,59 @@
         </p:nvSpPr>
         <p:spPr>
           <a:xfrm>
+            <a:off x="4908315" y="3898650"/>
+            <a:ext cx="1253400" cy="550800"/>
+          </a:xfrm>
+          <a:prstGeom prst="roundRect">
+            <a:avLst>
+              <a:gd fmla="val 16667" name="adj"/>
+            </a:avLst>
+          </a:prstGeom>
+          <a:solidFill>
+            <a:srgbClr val="FFAE88"/>
+          </a:solidFill>
+          <a:ln>
+            <a:noFill/>
+          </a:ln>
+        </p:spPr>
+        <p:txBody>
+          <a:bodyPr anchorCtr="0" anchor="ctr" bIns="91400" lIns="91400" spcFirstLastPara="1" rIns="91400" wrap="square" tIns="91400">
+            <a:noAutofit/>
+          </a:bodyPr>
+          <a:lstStyle/>
+          <a:p>
+            <a:pPr indent="0" lvl="0" marL="0" rtl="0" algn="ctr">
+              <a:spcBef>
+                <a:spcPts val="0"/>
+              </a:spcBef>
+              <a:spcAft>
+                <a:spcPts val="0"/>
+              </a:spcAft>
+              <a:buNone/>
+            </a:pPr>
+            <a:r>
+              <a:t/>
+            </a:r>
+            <a:endParaRPr i="0" sz="1000">
+              <a:solidFill>
+                <a:srgbClr val="FFFFFF"/>
+              </a:solidFill>
+              <a:latin typeface="Montserrat ExtraBold"/>
+              <a:ea typeface="Montserrat ExtraBold"/>
+              <a:cs typeface="Montserrat ExtraBold"/>
+              <a:sym typeface="Montserrat ExtraBold"/>
+            </a:endParaRPr>
+          </a:p>
+        </p:txBody>
+      </p:sp>
+      <p:sp>
+        <p:nvSpPr>
+          <p:cNvPr id="118" name="Google Shape;118;p17"/>
+          <p:cNvSpPr/>
+          <p:nvPr/>
+        </p:nvSpPr>
+        <p:spPr>
+          <a:xfrm>
             <a:off x="7833050" y="3872336"/>
             <a:ext cx="823200" cy="579000"/>
           </a:xfrm>
@@ -12256,7 +12314,7 @@
       </p:sp>
       <p:sp>
         <p:nvSpPr>
-          <p:cNvPr id="118" name="Google Shape;118;p17"/>
+          <p:cNvPr id="119" name="Google Shape;119;p17"/>
           <p:cNvSpPr/>
           <p:nvPr/>
         </p:nvSpPr>
@@ -12309,7 +12367,7 @@
       </p:sp>
       <p:sp>
         <p:nvSpPr>
-          <p:cNvPr id="119" name="Google Shape;119;p17"/>
+          <p:cNvPr id="120" name="Google Shape;120;p17"/>
           <p:cNvSpPr txBox="1"/>
           <p:nvPr/>
         </p:nvSpPr>
@@ -12367,7 +12425,7 @@
       </p:sp>
       <p:sp>
         <p:nvSpPr>
-          <p:cNvPr id="120" name="Google Shape;120;p17"/>
+          <p:cNvPr id="121" name="Google Shape;121;p17"/>
           <p:cNvSpPr/>
           <p:nvPr/>
         </p:nvSpPr>
@@ -12420,10 +12478,10 @@
       </p:sp>
       <p:cxnSp>
         <p:nvCxnSpPr>
-          <p:cNvPr id="121" name="Google Shape;121;p17"/>
+          <p:cNvPr id="122" name="Google Shape;122;p17"/>
           <p:cNvCxnSpPr>
-            <a:stCxn id="113" idx="3"/>
-            <a:endCxn id="118" idx="1"/>
+            <a:stCxn id="114" idx="3"/>
+            <a:endCxn id="119" idx="1"/>
           </p:cNvCxnSpPr>
           <p:nvPr/>
         </p:nvCxnSpPr>
@@ -12449,7 +12507,7 @@
       </p:cxnSp>
       <p:sp>
         <p:nvSpPr>
-          <p:cNvPr id="122" name="Google Shape;122;p17"/>
+          <p:cNvPr id="123" name="Google Shape;123;p17"/>
           <p:cNvSpPr/>
           <p:nvPr/>
         </p:nvSpPr>
@@ -12500,9 +12558,9 @@
       </p:sp>
       <p:cxnSp>
         <p:nvCxnSpPr>
-          <p:cNvPr id="123" name="Google Shape;123;p17"/>
+          <p:cNvPr id="124" name="Google Shape;124;p17"/>
           <p:cNvCxnSpPr>
-            <a:stCxn id="112" idx="3"/>
+            <a:stCxn id="113" idx="3"/>
           </p:cNvCxnSpPr>
           <p:nvPr/>
         </p:nvCxnSpPr>
@@ -12530,9 +12588,9 @@
       </p:cxnSp>
       <p:cxnSp>
         <p:nvCxnSpPr>
-          <p:cNvPr id="124" name="Google Shape;124;p17"/>
+          <p:cNvPr id="125" name="Google Shape;125;p17"/>
           <p:cNvCxnSpPr>
-            <a:stCxn id="111" idx="3"/>
+            <a:stCxn id="112" idx="3"/>
           </p:cNvCxnSpPr>
           <p:nvPr/>
         </p:nvCxnSpPr>
@@ -12560,9 +12618,9 @@
       </p:cxnSp>
       <p:cxnSp>
         <p:nvCxnSpPr>
-          <p:cNvPr id="125" name="Google Shape;125;p17"/>
+          <p:cNvPr id="126" name="Google Shape;126;p17"/>
           <p:cNvCxnSpPr>
-            <a:stCxn id="110" idx="3"/>
+            <a:stCxn id="111" idx="3"/>
           </p:cNvCxnSpPr>
           <p:nvPr/>
         </p:nvCxnSpPr>
@@ -12588,10 +12646,10 @@
       </p:cxnSp>
       <p:cxnSp>
         <p:nvCxnSpPr>
-          <p:cNvPr id="126" name="Google Shape;126;p17"/>
+          <p:cNvPr id="127" name="Google Shape;127;p17"/>
           <p:cNvCxnSpPr>
-            <a:stCxn id="114" idx="0"/>
-            <a:endCxn id="118" idx="3"/>
+            <a:stCxn id="115" idx="0"/>
+            <a:endCxn id="119" idx="3"/>
           </p:cNvCxnSpPr>
           <p:nvPr/>
         </p:nvCxnSpPr>
@@ -12620,65 +12678,14 @@
       </p:cxnSp>
       <p:sp>
         <p:nvSpPr>
-          <p:cNvPr id="127" name="Google Shape;127;p17"/>
-          <p:cNvSpPr/>
-          <p:nvPr/>
-        </p:nvSpPr>
-        <p:spPr>
-          <a:xfrm>
-            <a:off x="4596407" y="4054136"/>
-            <a:ext cx="364800" cy="215400"/>
-          </a:xfrm>
-          <a:prstGeom prst="rightArrow">
-            <a:avLst>
-              <a:gd fmla="val 50000" name="adj1"/>
-              <a:gd fmla="val 50000" name="adj2"/>
-            </a:avLst>
-          </a:prstGeom>
-          <a:solidFill>
-            <a:srgbClr val="D9D9D9"/>
-          </a:solidFill>
-          <a:ln>
-            <a:noFill/>
-          </a:ln>
-        </p:spPr>
-        <p:txBody>
-          <a:bodyPr anchorCtr="0" anchor="ctr" bIns="91425" lIns="91425" spcFirstLastPara="1" rIns="91425" wrap="square" tIns="91425">
-            <a:noAutofit/>
-          </a:bodyPr>
-          <a:lstStyle/>
-          <a:p>
-            <a:pPr indent="0" lvl="0" marL="0" rtl="0" algn="ctr">
-              <a:spcBef>
-                <a:spcPts val="0"/>
-              </a:spcBef>
-              <a:spcAft>
-                <a:spcPts val="0"/>
-              </a:spcAft>
-              <a:buNone/>
-            </a:pPr>
-            <a:r>
-              <a:t/>
-            </a:r>
-            <a:endParaRPr>
-              <a:latin typeface="Lato"/>
-              <a:ea typeface="Lato"/>
-              <a:cs typeface="Lato"/>
-              <a:sym typeface="Lato"/>
-            </a:endParaRPr>
-          </a:p>
-        </p:txBody>
-      </p:sp>
-      <p:sp>
-        <p:nvSpPr>
           <p:cNvPr id="128" name="Google Shape;128;p17"/>
           <p:cNvSpPr/>
           <p:nvPr/>
         </p:nvSpPr>
         <p:spPr>
           <a:xfrm>
-            <a:off x="6160623" y="4054125"/>
-            <a:ext cx="311400" cy="215400"/>
+            <a:off x="4596407" y="4054136"/>
+            <a:ext cx="364800" cy="215400"/>
           </a:xfrm>
           <a:prstGeom prst="rightArrow">
             <a:avLst>
@@ -12728,8 +12735,8 @@
         </p:nvSpPr>
         <p:spPr>
           <a:xfrm>
-            <a:off x="7670849" y="4054125"/>
-            <a:ext cx="244800" cy="215400"/>
+            <a:off x="6160623" y="4054125"/>
+            <a:ext cx="311400" cy="215400"/>
           </a:xfrm>
           <a:prstGeom prst="rightArrow">
             <a:avLst>
@@ -12774,6 +12781,57 @@
       <p:sp>
         <p:nvSpPr>
           <p:cNvPr id="130" name="Google Shape;130;p17"/>
+          <p:cNvSpPr/>
+          <p:nvPr/>
+        </p:nvSpPr>
+        <p:spPr>
+          <a:xfrm>
+            <a:off x="7670849" y="4054125"/>
+            <a:ext cx="244800" cy="215400"/>
+          </a:xfrm>
+          <a:prstGeom prst="rightArrow">
+            <a:avLst>
+              <a:gd fmla="val 50000" name="adj1"/>
+              <a:gd fmla="val 50000" name="adj2"/>
+            </a:avLst>
+          </a:prstGeom>
+          <a:solidFill>
+            <a:srgbClr val="D9D9D9"/>
+          </a:solidFill>
+          <a:ln>
+            <a:noFill/>
+          </a:ln>
+        </p:spPr>
+        <p:txBody>
+          <a:bodyPr anchorCtr="0" anchor="ctr" bIns="91425" lIns="91425" spcFirstLastPara="1" rIns="91425" wrap="square" tIns="91425">
+            <a:noAutofit/>
+          </a:bodyPr>
+          <a:lstStyle/>
+          <a:p>
+            <a:pPr indent="0" lvl="0" marL="0" rtl="0" algn="ctr">
+              <a:spcBef>
+                <a:spcPts val="0"/>
+              </a:spcBef>
+              <a:spcAft>
+                <a:spcPts val="0"/>
+              </a:spcAft>
+              <a:buNone/>
+            </a:pPr>
+            <a:r>
+              <a:t/>
+            </a:r>
+            <a:endParaRPr>
+              <a:latin typeface="Lato"/>
+              <a:ea typeface="Lato"/>
+              <a:cs typeface="Lato"/>
+              <a:sym typeface="Lato"/>
+            </a:endParaRPr>
+          </a:p>
+        </p:txBody>
+      </p:sp>
+      <p:sp>
+        <p:nvSpPr>
+          <p:cNvPr id="131" name="Google Shape;131;p17"/>
           <p:cNvSpPr txBox="1"/>
           <p:nvPr/>
         </p:nvSpPr>
@@ -12831,7 +12889,7 @@
       </p:sp>
       <p:sp>
         <p:nvSpPr>
-          <p:cNvPr id="131" name="Google Shape;131;p17"/>
+          <p:cNvPr id="132" name="Google Shape;132;p17"/>
           <p:cNvSpPr txBox="1"/>
           <p:nvPr/>
         </p:nvSpPr>
@@ -12889,7 +12947,7 @@
       </p:sp>
       <p:sp>
         <p:nvSpPr>
-          <p:cNvPr id="132" name="Google Shape;132;p17"/>
+          <p:cNvPr id="133" name="Google Shape;133;p17"/>
           <p:cNvSpPr txBox="1"/>
           <p:nvPr/>
         </p:nvSpPr>
@@ -12947,7 +13005,7 @@
       </p:sp>
       <p:sp>
         <p:nvSpPr>
-          <p:cNvPr id="133" name="Google Shape;133;p17"/>
+          <p:cNvPr id="134" name="Google Shape;134;p17"/>
           <p:cNvSpPr txBox="1"/>
           <p:nvPr/>
         </p:nvSpPr>
@@ -13005,7 +13063,7 @@
       </p:sp>
       <p:sp>
         <p:nvSpPr>
-          <p:cNvPr id="134" name="Google Shape;134;p17"/>
+          <p:cNvPr id="135" name="Google Shape;135;p17"/>
           <p:cNvSpPr txBox="1"/>
           <p:nvPr/>
         </p:nvSpPr>
@@ -13063,7 +13121,7 @@
       </p:sp>
       <p:sp>
         <p:nvSpPr>
-          <p:cNvPr id="135" name="Google Shape;135;p17"/>
+          <p:cNvPr id="136" name="Google Shape;136;p17"/>
           <p:cNvSpPr txBox="1"/>
           <p:nvPr/>
         </p:nvSpPr>
@@ -13121,7 +13179,7 @@
       </p:sp>
       <p:sp>
         <p:nvSpPr>
-          <p:cNvPr id="136" name="Google Shape;136;p17"/>
+          <p:cNvPr id="137" name="Google Shape;137;p17"/>
           <p:cNvSpPr txBox="1"/>
           <p:nvPr/>
         </p:nvSpPr>
@@ -13179,7 +13237,7 @@
       </p:sp>
       <p:sp>
         <p:nvSpPr>
-          <p:cNvPr id="137" name="Google Shape;137;p17"/>
+          <p:cNvPr id="138" name="Google Shape;138;p17"/>
           <p:cNvSpPr txBox="1"/>
           <p:nvPr/>
         </p:nvSpPr>
@@ -13237,7 +13295,7 @@
       </p:sp>
       <p:sp>
         <p:nvSpPr>
-          <p:cNvPr id="138" name="Google Shape;138;p17"/>
+          <p:cNvPr id="139" name="Google Shape;139;p17"/>
           <p:cNvSpPr txBox="1"/>
           <p:nvPr/>
         </p:nvSpPr>
@@ -13295,9 +13353,9 @@
       </p:sp>
       <p:cxnSp>
         <p:nvCxnSpPr>
-          <p:cNvPr id="139" name="Google Shape;139;p17"/>
+          <p:cNvPr id="140" name="Google Shape;140;p17"/>
           <p:cNvCxnSpPr>
-            <a:stCxn id="120" idx="0"/>
+            <a:stCxn id="121" idx="0"/>
           </p:cNvCxnSpPr>
           <p:nvPr/>
         </p:nvCxnSpPr>
@@ -13325,7 +13383,7 @@
       </p:cxnSp>
       <p:sp>
         <p:nvSpPr>
-          <p:cNvPr id="140" name="Google Shape;140;p17"/>
+          <p:cNvPr id="141" name="Google Shape;141;p17"/>
           <p:cNvSpPr txBox="1"/>
           <p:nvPr/>
         </p:nvSpPr>
@@ -13383,7 +13441,7 @@
       </p:sp>
       <p:sp>
         <p:nvSpPr>
-          <p:cNvPr id="141" name="Google Shape;141;p17"/>
+          <p:cNvPr id="142" name="Google Shape;142;p17"/>
           <p:cNvSpPr txBox="1"/>
           <p:nvPr/>
         </p:nvSpPr>
@@ -13453,7 +13511,7 @@
       </p:sp>
       <p:sp>
         <p:nvSpPr>
-          <p:cNvPr id="142" name="Google Shape;142;p17"/>
+          <p:cNvPr id="143" name="Google Shape;143;p17"/>
           <p:cNvSpPr txBox="1"/>
           <p:nvPr/>
         </p:nvSpPr>
@@ -13535,7 +13593,7 @@
       </p:sp>
       <p:sp>
         <p:nvSpPr>
-          <p:cNvPr id="143" name="Google Shape;143;p17"/>
+          <p:cNvPr id="144" name="Google Shape;144;p17"/>
           <p:cNvSpPr txBox="1"/>
           <p:nvPr/>
         </p:nvSpPr>
@@ -13593,7 +13651,7 @@
       </p:sp>
       <p:sp>
         <p:nvSpPr>
-          <p:cNvPr id="144" name="Google Shape;144;p17"/>
+          <p:cNvPr id="145" name="Google Shape;145;p17"/>
           <p:cNvSpPr txBox="1"/>
           <p:nvPr/>
         </p:nvSpPr>
@@ -13651,7 +13709,7 @@
       </p:sp>
       <p:sp>
         <p:nvSpPr>
-          <p:cNvPr id="145" name="Google Shape;145;p17"/>
+          <p:cNvPr id="146" name="Google Shape;146;p17"/>
           <p:cNvSpPr txBox="1"/>
           <p:nvPr/>
         </p:nvSpPr>
@@ -13709,7 +13767,7 @@
       </p:sp>
       <p:sp>
         <p:nvSpPr>
-          <p:cNvPr id="146" name="Google Shape;146;p17"/>
+          <p:cNvPr id="147" name="Google Shape;147;p17"/>
           <p:cNvSpPr txBox="1"/>
           <p:nvPr/>
         </p:nvSpPr>
@@ -13767,7 +13825,7 @@
       </p:sp>
       <p:sp>
         <p:nvSpPr>
-          <p:cNvPr id="147" name="Google Shape;147;p17"/>
+          <p:cNvPr id="148" name="Google Shape;148;p17"/>
           <p:cNvSpPr txBox="1"/>
           <p:nvPr/>
         </p:nvSpPr>
@@ -13825,7 +13883,7 @@
       </p:sp>
       <p:sp>
         <p:nvSpPr>
-          <p:cNvPr id="148" name="Google Shape;148;p17"/>
+          <p:cNvPr id="149" name="Google Shape;149;p17"/>
           <p:cNvSpPr txBox="1"/>
           <p:nvPr/>
         </p:nvSpPr>
@@ -13883,7 +13941,7 @@
       </p:sp>
       <p:sp>
         <p:nvSpPr>
-          <p:cNvPr id="149" name="Google Shape;149;p17"/>
+          <p:cNvPr id="150" name="Google Shape;150;p17"/>
           <p:cNvSpPr/>
           <p:nvPr/>
         </p:nvSpPr>
@@ -13936,64 +13994,13 @@
       </p:sp>
       <p:sp>
         <p:nvSpPr>
-          <p:cNvPr id="150" name="Google Shape;150;p17"/>
-          <p:cNvSpPr/>
-          <p:nvPr/>
-        </p:nvSpPr>
-        <p:spPr>
-          <a:xfrm>
-            <a:off x="3049885" y="4068811"/>
-            <a:ext cx="364800" cy="215400"/>
-          </a:xfrm>
-          <a:prstGeom prst="rightArrow">
-            <a:avLst>
-              <a:gd fmla="val 50000" name="adj1"/>
-              <a:gd fmla="val 50000" name="adj2"/>
-            </a:avLst>
-          </a:prstGeom>
-          <a:solidFill>
-            <a:srgbClr val="D9D9D9"/>
-          </a:solidFill>
-          <a:ln>
-            <a:noFill/>
-          </a:ln>
-        </p:spPr>
-        <p:txBody>
-          <a:bodyPr anchorCtr="0" anchor="ctr" bIns="91425" lIns="91425" spcFirstLastPara="1" rIns="91425" wrap="square" tIns="91425">
-            <a:noAutofit/>
-          </a:bodyPr>
-          <a:lstStyle/>
-          <a:p>
-            <a:pPr indent="0" lvl="0" marL="0" rtl="0" algn="ctr">
-              <a:spcBef>
-                <a:spcPts val="0"/>
-              </a:spcBef>
-              <a:spcAft>
-                <a:spcPts val="0"/>
-              </a:spcAft>
-              <a:buNone/>
-            </a:pPr>
-            <a:r>
-              <a:t/>
-            </a:r>
-            <a:endParaRPr>
-              <a:latin typeface="Lato"/>
-              <a:ea typeface="Lato"/>
-              <a:cs typeface="Lato"/>
-              <a:sym typeface="Lato"/>
-            </a:endParaRPr>
-          </a:p>
-        </p:txBody>
-      </p:sp>
-      <p:sp>
-        <p:nvSpPr>
           <p:cNvPr id="151" name="Google Shape;151;p17"/>
           <p:cNvSpPr/>
           <p:nvPr/>
         </p:nvSpPr>
         <p:spPr>
           <a:xfrm>
-            <a:off x="1503360" y="4068811"/>
+            <a:off x="3049885" y="4068811"/>
             <a:ext cx="364800" cy="215400"/>
           </a:xfrm>
           <a:prstGeom prst="rightArrow">
@@ -14039,6 +14046,57 @@
       <p:sp>
         <p:nvSpPr>
           <p:cNvPr id="152" name="Google Shape;152;p17"/>
+          <p:cNvSpPr/>
+          <p:nvPr/>
+        </p:nvSpPr>
+        <p:spPr>
+          <a:xfrm>
+            <a:off x="1503360" y="4068811"/>
+            <a:ext cx="364800" cy="215400"/>
+          </a:xfrm>
+          <a:prstGeom prst="rightArrow">
+            <a:avLst>
+              <a:gd fmla="val 50000" name="adj1"/>
+              <a:gd fmla="val 50000" name="adj2"/>
+            </a:avLst>
+          </a:prstGeom>
+          <a:solidFill>
+            <a:srgbClr val="D9D9D9"/>
+          </a:solidFill>
+          <a:ln>
+            <a:noFill/>
+          </a:ln>
+        </p:spPr>
+        <p:txBody>
+          <a:bodyPr anchorCtr="0" anchor="ctr" bIns="91425" lIns="91425" spcFirstLastPara="1" rIns="91425" wrap="square" tIns="91425">
+            <a:noAutofit/>
+          </a:bodyPr>
+          <a:lstStyle/>
+          <a:p>
+            <a:pPr indent="0" lvl="0" marL="0" rtl="0" algn="ctr">
+              <a:spcBef>
+                <a:spcPts val="0"/>
+              </a:spcBef>
+              <a:spcAft>
+                <a:spcPts val="0"/>
+              </a:spcAft>
+              <a:buNone/>
+            </a:pPr>
+            <a:r>
+              <a:t/>
+            </a:r>
+            <a:endParaRPr>
+              <a:latin typeface="Lato"/>
+              <a:ea typeface="Lato"/>
+              <a:cs typeface="Lato"/>
+              <a:sym typeface="Lato"/>
+            </a:endParaRPr>
+          </a:p>
+        </p:txBody>
+      </p:sp>
+      <p:sp>
+        <p:nvSpPr>
+          <p:cNvPr id="153" name="Google Shape;153;p17"/>
           <p:cNvSpPr txBox="1"/>
           <p:nvPr/>
         </p:nvSpPr>
@@ -14096,7 +14154,7 @@
       </p:sp>
       <p:sp>
         <p:nvSpPr>
-          <p:cNvPr id="153" name="Google Shape;153;p17"/>
+          <p:cNvPr id="154" name="Google Shape;154;p17"/>
           <p:cNvSpPr txBox="1"/>
           <p:nvPr/>
         </p:nvSpPr>
@@ -14154,7 +14212,7 @@
       </p:sp>
       <p:pic>
         <p:nvPicPr>
-          <p:cNvPr id="154" name="Google Shape;154;p17"/>
+          <p:cNvPr id="155" name="Google Shape;155;p17"/>
           <p:cNvPicPr preferRelativeResize="0"/>
           <p:nvPr/>
         </p:nvPicPr>
@@ -14184,7 +14242,7 @@
       </p:pic>
       <p:sp>
         <p:nvSpPr>
-          <p:cNvPr id="155" name="Google Shape;155;p17"/>
+          <p:cNvPr id="156" name="Google Shape;156;p17"/>
           <p:cNvSpPr txBox="1"/>
           <p:nvPr/>
         </p:nvSpPr>
@@ -14270,7 +14328,7 @@
       </p:sp>
       <p:pic>
         <p:nvPicPr>
-          <p:cNvPr id="156" name="Google Shape;156;p17"/>
+          <p:cNvPr id="157" name="Google Shape;157;p17"/>
           <p:cNvPicPr preferRelativeResize="0"/>
           <p:nvPr/>
         </p:nvPicPr>
@@ -14298,7 +14356,7 @@
       </p:pic>
       <p:sp>
         <p:nvSpPr>
-          <p:cNvPr id="157" name="Google Shape;157;p17"/>
+          <p:cNvPr id="158" name="Google Shape;158;p17"/>
           <p:cNvSpPr txBox="1"/>
           <p:nvPr/>
         </p:nvSpPr>
@@ -14356,7 +14414,7 @@
       </p:sp>
       <p:pic>
         <p:nvPicPr>
-          <p:cNvPr id="158" name="Google Shape;158;p17"/>
+          <p:cNvPr id="159" name="Google Shape;159;p17"/>
           <p:cNvPicPr preferRelativeResize="0"/>
           <p:nvPr/>
         </p:nvPicPr>
@@ -14384,7 +14442,7 @@
       </p:pic>
       <p:sp>
         <p:nvSpPr>
-          <p:cNvPr id="159" name="Google Shape;159;p17"/>
+          <p:cNvPr id="160" name="Google Shape;160;p17"/>
           <p:cNvSpPr txBox="1"/>
           <p:nvPr/>
         </p:nvSpPr>
@@ -14442,7 +14500,7 @@
       </p:sp>
       <p:sp>
         <p:nvSpPr>
-          <p:cNvPr id="160" name="Google Shape;160;p17"/>
+          <p:cNvPr id="161" name="Google Shape;161;p17"/>
           <p:cNvSpPr txBox="1"/>
           <p:nvPr/>
         </p:nvSpPr>
@@ -14540,7 +14598,7 @@
       </p:sp>
       <p:pic>
         <p:nvPicPr>
-          <p:cNvPr id="161" name="Google Shape;161;p17"/>
+          <p:cNvPr id="162" name="Google Shape;162;p17"/>
           <p:cNvPicPr preferRelativeResize="0"/>
           <p:nvPr/>
         </p:nvPicPr>
@@ -14568,7 +14626,7 @@
       </p:pic>
       <p:pic>
         <p:nvPicPr>
-          <p:cNvPr id="162" name="Google Shape;162;p17"/>
+          <p:cNvPr id="163" name="Google Shape;163;p17"/>
           <p:cNvPicPr preferRelativeResize="0"/>
           <p:nvPr/>
         </p:nvPicPr>
@@ -14596,7 +14654,7 @@
       </p:pic>
       <p:sp>
         <p:nvSpPr>
-          <p:cNvPr id="163" name="Google Shape;163;p17"/>
+          <p:cNvPr id="164" name="Google Shape;164;p17"/>
           <p:cNvSpPr txBox="1"/>
           <p:nvPr/>
         </p:nvSpPr>
@@ -14682,7 +14740,7 @@
       </p:sp>
       <p:pic>
         <p:nvPicPr>
-          <p:cNvPr id="164" name="Google Shape;164;p17"/>
+          <p:cNvPr id="165" name="Google Shape;165;p17"/>
           <p:cNvPicPr preferRelativeResize="0"/>
           <p:nvPr/>
         </p:nvPicPr>
@@ -14710,7 +14768,7 @@
       </p:pic>
       <p:sp>
         <p:nvSpPr>
-          <p:cNvPr id="165" name="Google Shape;165;p17"/>
+          <p:cNvPr id="166" name="Google Shape;166;p17"/>
           <p:cNvSpPr txBox="1"/>
           <p:nvPr/>
         </p:nvSpPr>
@@ -14796,7 +14854,7 @@
       </p:sp>
       <p:sp>
         <p:nvSpPr>
-          <p:cNvPr id="166" name="Google Shape;166;p17"/>
+          <p:cNvPr id="167" name="Google Shape;167;p17"/>
           <p:cNvSpPr/>
           <p:nvPr/>
         </p:nvSpPr>
@@ -14847,7 +14905,7 @@
       </p:sp>
       <p:pic>
         <p:nvPicPr>
-          <p:cNvPr id="167" name="Google Shape;167;p17"/>
+          <p:cNvPr id="168" name="Google Shape;168;p17"/>
           <p:cNvPicPr preferRelativeResize="0"/>
           <p:nvPr/>
         </p:nvPicPr>
@@ -14875,7 +14933,7 @@
       </p:pic>
       <p:sp>
         <p:nvSpPr>
-          <p:cNvPr id="168" name="Google Shape;168;p17"/>
+          <p:cNvPr id="169" name="Google Shape;169;p17"/>
           <p:cNvSpPr txBox="1"/>
           <p:nvPr/>
         </p:nvSpPr>
@@ -14938,7 +14996,7 @@
       </p:sp>
       <p:pic>
         <p:nvPicPr>
-          <p:cNvPr id="169" name="Google Shape;169;p17"/>
+          <p:cNvPr id="170" name="Google Shape;170;p17"/>
           <p:cNvPicPr preferRelativeResize="0"/>
           <p:nvPr/>
         </p:nvPicPr>
@@ -14966,7 +15024,7 @@
       </p:pic>
       <p:sp>
         <p:nvSpPr>
-          <p:cNvPr id="170" name="Google Shape;170;p17"/>
+          <p:cNvPr id="171" name="Google Shape;171;p17"/>
           <p:cNvSpPr txBox="1"/>
           <p:nvPr/>
         </p:nvSpPr>
@@ -15052,7 +15110,7 @@
       </p:sp>
       <p:pic>
         <p:nvPicPr>
-          <p:cNvPr id="171" name="Google Shape;171;p17"/>
+          <p:cNvPr id="172" name="Google Shape;172;p17"/>
           <p:cNvPicPr preferRelativeResize="0"/>
           <p:nvPr/>
         </p:nvPicPr>
@@ -15080,7 +15138,7 @@
       </p:pic>
       <p:sp>
         <p:nvSpPr>
-          <p:cNvPr id="172" name="Google Shape;172;p17"/>
+          <p:cNvPr id="173" name="Google Shape;173;p17"/>
           <p:cNvSpPr txBox="1"/>
           <p:nvPr/>
         </p:nvSpPr>
@@ -15166,7 +15224,7 @@
       </p:sp>
       <p:pic>
         <p:nvPicPr>
-          <p:cNvPr id="173" name="Google Shape;173;p17"/>
+          <p:cNvPr id="174" name="Google Shape;174;p17"/>
           <p:cNvPicPr preferRelativeResize="0"/>
           <p:nvPr/>
         </p:nvPicPr>
@@ -15194,7 +15252,7 @@
       </p:pic>
       <p:sp>
         <p:nvSpPr>
-          <p:cNvPr id="174" name="Google Shape;174;p17"/>
+          <p:cNvPr id="175" name="Google Shape;175;p17"/>
           <p:cNvSpPr txBox="1"/>
           <p:nvPr/>
         </p:nvSpPr>
@@ -15298,7 +15356,7 @@
     </p:bg>
     <p:spTree>
       <p:nvGrpSpPr>
-        <p:cNvPr id="178" name="Shape 178"/>
+        <p:cNvPr id="179" name="Shape 179"/>
         <p:cNvGrpSpPr/>
         <p:nvPr/>
       </p:nvGrpSpPr>
@@ -15310,34 +15368,6 @@
           <a:chExt cx="0" cy="0"/>
         </a:xfrm>
       </p:grpSpPr>
-      <p:pic>
-        <p:nvPicPr>
-          <p:cNvPr id="179" name="Google Shape;179;p18"/>
-          <p:cNvPicPr preferRelativeResize="0"/>
-          <p:nvPr/>
-        </p:nvPicPr>
-        <p:blipFill>
-          <a:blip r:embed="rId3">
-            <a:alphaModFix amt="50000"/>
-          </a:blip>
-          <a:stretch>
-            <a:fillRect/>
-          </a:stretch>
-        </p:blipFill>
-        <p:spPr>
-          <a:xfrm>
-            <a:off x="4302325" y="348338"/>
-            <a:ext cx="4446825" cy="4446825"/>
-          </a:xfrm>
-          <a:prstGeom prst="rect">
-            <a:avLst/>
-          </a:prstGeom>
-          <a:noFill/>
-          <a:ln>
-            <a:noFill/>
-          </a:ln>
-        </p:spPr>
-      </p:pic>
       <p:pic>
         <p:nvPicPr>
           <p:cNvPr id="180" name="Google Shape;180;p18"/>
@@ -15354,7 +15384,7 @@
         </p:blipFill>
         <p:spPr>
           <a:xfrm>
-            <a:off x="315700" y="348338"/>
+            <a:off x="4302325" y="348338"/>
             <a:ext cx="4446825" cy="4446825"/>
           </a:xfrm>
           <a:prstGeom prst="rect">
@@ -15369,6 +15399,34 @@
       <p:pic>
         <p:nvPicPr>
           <p:cNvPr id="181" name="Google Shape;181;p18"/>
+          <p:cNvPicPr preferRelativeResize="0"/>
+          <p:nvPr/>
+        </p:nvPicPr>
+        <p:blipFill>
+          <a:blip r:embed="rId3">
+            <a:alphaModFix amt="50000"/>
+          </a:blip>
+          <a:stretch>
+            <a:fillRect/>
+          </a:stretch>
+        </p:blipFill>
+        <p:spPr>
+          <a:xfrm>
+            <a:off x="315700" y="348338"/>
+            <a:ext cx="4446825" cy="4446825"/>
+          </a:xfrm>
+          <a:prstGeom prst="rect">
+            <a:avLst/>
+          </a:prstGeom>
+          <a:noFill/>
+          <a:ln>
+            <a:noFill/>
+          </a:ln>
+        </p:spPr>
+      </p:pic>
+      <p:pic>
+        <p:nvPicPr>
+          <p:cNvPr id="182" name="Google Shape;182;p18"/>
           <p:cNvPicPr preferRelativeResize="0"/>
           <p:nvPr/>
         </p:nvPicPr>
@@ -15396,7 +15454,7 @@
       </p:pic>
       <p:sp>
         <p:nvSpPr>
-          <p:cNvPr id="182" name="Google Shape;182;p18"/>
+          <p:cNvPr id="183" name="Google Shape;183;p18"/>
           <p:cNvSpPr txBox="1"/>
           <p:nvPr/>
         </p:nvSpPr>
@@ -15454,7 +15512,7 @@
       </p:sp>
       <p:sp>
         <p:nvSpPr>
-          <p:cNvPr id="183" name="Google Shape;183;p18"/>
+          <p:cNvPr id="184" name="Google Shape;184;p18"/>
           <p:cNvSpPr txBox="1"/>
           <p:nvPr>
             <p:ph idx="4294967295" type="body"/>
@@ -15627,7 +15685,7 @@
       </p:sp>
       <p:pic>
         <p:nvPicPr>
-          <p:cNvPr id="184" name="Google Shape;184;p18"/>
+          <p:cNvPr id="185" name="Google Shape;185;p18"/>
           <p:cNvPicPr preferRelativeResize="0"/>
           <p:nvPr/>
         </p:nvPicPr>
@@ -15673,7 +15731,7 @@
     </p:bg>
     <p:spTree>
       <p:nvGrpSpPr>
-        <p:cNvPr id="188" name="Shape 188"/>
+        <p:cNvPr id="189" name="Shape 189"/>
         <p:cNvGrpSpPr/>
         <p:nvPr/>
       </p:nvGrpSpPr>
@@ -15685,34 +15743,6 @@
           <a:chExt cx="0" cy="0"/>
         </a:xfrm>
       </p:grpSpPr>
-      <p:pic>
-        <p:nvPicPr>
-          <p:cNvPr id="189" name="Google Shape;189;p19"/>
-          <p:cNvPicPr preferRelativeResize="0"/>
-          <p:nvPr/>
-        </p:nvPicPr>
-        <p:blipFill>
-          <a:blip r:embed="rId3">
-            <a:alphaModFix amt="50000"/>
-          </a:blip>
-          <a:stretch>
-            <a:fillRect/>
-          </a:stretch>
-        </p:blipFill>
-        <p:spPr>
-          <a:xfrm>
-            <a:off x="4422325" y="377650"/>
-            <a:ext cx="4133850" cy="4133850"/>
-          </a:xfrm>
-          <a:prstGeom prst="rect">
-            <a:avLst/>
-          </a:prstGeom>
-          <a:noFill/>
-          <a:ln>
-            <a:noFill/>
-          </a:ln>
-        </p:spPr>
-      </p:pic>
       <p:pic>
         <p:nvPicPr>
           <p:cNvPr id="190" name="Google Shape;190;p19"/>
@@ -15729,7 +15759,7 @@
         </p:blipFill>
         <p:spPr>
           <a:xfrm>
-            <a:off x="438150" y="377650"/>
+            <a:off x="4422325" y="377650"/>
             <a:ext cx="4133850" cy="4133850"/>
           </a:xfrm>
           <a:prstGeom prst="rect">
@@ -15744,6 +15774,34 @@
       <p:pic>
         <p:nvPicPr>
           <p:cNvPr id="191" name="Google Shape;191;p19"/>
+          <p:cNvPicPr preferRelativeResize="0"/>
+          <p:nvPr/>
+        </p:nvPicPr>
+        <p:blipFill>
+          <a:blip r:embed="rId3">
+            <a:alphaModFix amt="50000"/>
+          </a:blip>
+          <a:stretch>
+            <a:fillRect/>
+          </a:stretch>
+        </p:blipFill>
+        <p:spPr>
+          <a:xfrm>
+            <a:off x="438150" y="377650"/>
+            <a:ext cx="4133850" cy="4133850"/>
+          </a:xfrm>
+          <a:prstGeom prst="rect">
+            <a:avLst/>
+          </a:prstGeom>
+          <a:noFill/>
+          <a:ln>
+            <a:noFill/>
+          </a:ln>
+        </p:spPr>
+      </p:pic>
+      <p:pic>
+        <p:nvPicPr>
+          <p:cNvPr id="192" name="Google Shape;192;p19"/>
           <p:cNvPicPr preferRelativeResize="0"/>
           <p:nvPr/>
         </p:nvPicPr>
@@ -15771,7 +15829,7 @@
       </p:pic>
       <p:sp>
         <p:nvSpPr>
-          <p:cNvPr id="192" name="Google Shape;192;p19"/>
+          <p:cNvPr id="193" name="Google Shape;193;p19"/>
           <p:cNvSpPr txBox="1"/>
           <p:nvPr/>
         </p:nvSpPr>
@@ -15829,7 +15887,7 @@
       </p:sp>
       <p:sp>
         <p:nvSpPr>
-          <p:cNvPr id="193" name="Google Shape;193;p19"/>
+          <p:cNvPr id="194" name="Google Shape;194;p19"/>
           <p:cNvSpPr txBox="1"/>
           <p:nvPr>
             <p:ph idx="4294967295" type="body"/>
@@ -15967,7 +16025,7 @@
       </p:sp>
       <p:pic>
         <p:nvPicPr>
-          <p:cNvPr id="194" name="Google Shape;194;p19"/>
+          <p:cNvPr id="195" name="Google Shape;195;p19"/>
           <p:cNvPicPr preferRelativeResize="0"/>
           <p:nvPr/>
         </p:nvPicPr>
@@ -16013,7 +16071,7 @@
     </p:bg>
     <p:spTree>
       <p:nvGrpSpPr>
-        <p:cNvPr id="198" name="Shape 198"/>
+        <p:cNvPr id="199" name="Shape 199"/>
         <p:cNvGrpSpPr/>
         <p:nvPr/>
       </p:nvGrpSpPr>
@@ -16025,34 +16083,6 @@
           <a:chExt cx="0" cy="0"/>
         </a:xfrm>
       </p:grpSpPr>
-      <p:pic>
-        <p:nvPicPr>
-          <p:cNvPr id="199" name="Google Shape;199;p20"/>
-          <p:cNvPicPr preferRelativeResize="0"/>
-          <p:nvPr/>
-        </p:nvPicPr>
-        <p:blipFill>
-          <a:blip r:embed="rId3">
-            <a:alphaModFix amt="50000"/>
-          </a:blip>
-          <a:stretch>
-            <a:fillRect/>
-          </a:stretch>
-        </p:blipFill>
-        <p:spPr>
-          <a:xfrm>
-            <a:off x="4572000" y="603650"/>
-            <a:ext cx="3936200" cy="3936200"/>
-          </a:xfrm>
-          <a:prstGeom prst="rect">
-            <a:avLst/>
-          </a:prstGeom>
-          <a:noFill/>
-          <a:ln>
-            <a:noFill/>
-          </a:ln>
-        </p:spPr>
-      </p:pic>
       <p:pic>
         <p:nvPicPr>
           <p:cNvPr id="200" name="Google Shape;200;p20"/>
@@ -16069,7 +16099,7 @@
         </p:blipFill>
         <p:spPr>
           <a:xfrm>
-            <a:off x="635800" y="603650"/>
+            <a:off x="4572000" y="603650"/>
             <a:ext cx="3936200" cy="3936200"/>
           </a:xfrm>
           <a:prstGeom prst="rect">
@@ -16084,6 +16114,34 @@
       <p:pic>
         <p:nvPicPr>
           <p:cNvPr id="201" name="Google Shape;201;p20"/>
+          <p:cNvPicPr preferRelativeResize="0"/>
+          <p:nvPr/>
+        </p:nvPicPr>
+        <p:blipFill>
+          <a:blip r:embed="rId3">
+            <a:alphaModFix amt="50000"/>
+          </a:blip>
+          <a:stretch>
+            <a:fillRect/>
+          </a:stretch>
+        </p:blipFill>
+        <p:spPr>
+          <a:xfrm>
+            <a:off x="635800" y="603650"/>
+            <a:ext cx="3936200" cy="3936200"/>
+          </a:xfrm>
+          <a:prstGeom prst="rect">
+            <a:avLst/>
+          </a:prstGeom>
+          <a:noFill/>
+          <a:ln>
+            <a:noFill/>
+          </a:ln>
+        </p:spPr>
+      </p:pic>
+      <p:pic>
+        <p:nvPicPr>
+          <p:cNvPr id="202" name="Google Shape;202;p20"/>
           <p:cNvPicPr preferRelativeResize="0"/>
           <p:nvPr/>
         </p:nvPicPr>
@@ -16111,7 +16169,7 @@
       </p:pic>
       <p:sp>
         <p:nvSpPr>
-          <p:cNvPr id="202" name="Google Shape;202;p20"/>
+          <p:cNvPr id="203" name="Google Shape;203;p20"/>
           <p:cNvSpPr txBox="1"/>
           <p:nvPr/>
         </p:nvSpPr>
@@ -16169,7 +16227,7 @@
       </p:sp>
       <p:sp>
         <p:nvSpPr>
-          <p:cNvPr id="203" name="Google Shape;203;p20"/>
+          <p:cNvPr id="204" name="Google Shape;204;p20"/>
           <p:cNvSpPr txBox="1"/>
           <p:nvPr>
             <p:ph idx="4294967295" type="body"/>
@@ -16311,7 +16369,7 @@
       </p:sp>
       <p:pic>
         <p:nvPicPr>
-          <p:cNvPr id="204" name="Google Shape;204;p20"/>
+          <p:cNvPr id="205" name="Google Shape;205;p20"/>
           <p:cNvPicPr preferRelativeResize="0"/>
           <p:nvPr/>
         </p:nvPicPr>
@@ -16357,7 +16415,7 @@
     </p:bg>
     <p:spTree>
       <p:nvGrpSpPr>
-        <p:cNvPr id="208" name="Shape 208"/>
+        <p:cNvPr id="209" name="Shape 209"/>
         <p:cNvGrpSpPr/>
         <p:nvPr/>
       </p:nvGrpSpPr>
@@ -16369,34 +16427,6 @@
           <a:chExt cx="0" cy="0"/>
         </a:xfrm>
       </p:grpSpPr>
-      <p:pic>
-        <p:nvPicPr>
-          <p:cNvPr id="209" name="Google Shape;209;p21"/>
-          <p:cNvPicPr preferRelativeResize="0"/>
-          <p:nvPr/>
-        </p:nvPicPr>
-        <p:blipFill>
-          <a:blip r:embed="rId3">
-            <a:alphaModFix amt="50000"/>
-          </a:blip>
-          <a:stretch>
-            <a:fillRect/>
-          </a:stretch>
-        </p:blipFill>
-        <p:spPr>
-          <a:xfrm>
-            <a:off x="4647658" y="689662"/>
-            <a:ext cx="3764175" cy="3764175"/>
-          </a:xfrm>
-          <a:prstGeom prst="rect">
-            <a:avLst/>
-          </a:prstGeom>
-          <a:noFill/>
-          <a:ln>
-            <a:noFill/>
-          </a:ln>
-        </p:spPr>
-      </p:pic>
       <p:pic>
         <p:nvPicPr>
           <p:cNvPr id="210" name="Google Shape;210;p21"/>
@@ -16413,7 +16443,7 @@
         </p:blipFill>
         <p:spPr>
           <a:xfrm>
-            <a:off x="725225" y="689662"/>
+            <a:off x="4647658" y="689662"/>
             <a:ext cx="3764175" cy="3764175"/>
           </a:xfrm>
           <a:prstGeom prst="rect">
@@ -16428,6 +16458,34 @@
       <p:pic>
         <p:nvPicPr>
           <p:cNvPr id="211" name="Google Shape;211;p21"/>
+          <p:cNvPicPr preferRelativeResize="0"/>
+          <p:nvPr/>
+        </p:nvPicPr>
+        <p:blipFill>
+          <a:blip r:embed="rId3">
+            <a:alphaModFix amt="50000"/>
+          </a:blip>
+          <a:stretch>
+            <a:fillRect/>
+          </a:stretch>
+        </p:blipFill>
+        <p:spPr>
+          <a:xfrm>
+            <a:off x="725225" y="689662"/>
+            <a:ext cx="3764175" cy="3764175"/>
+          </a:xfrm>
+          <a:prstGeom prst="rect">
+            <a:avLst/>
+          </a:prstGeom>
+          <a:noFill/>
+          <a:ln>
+            <a:noFill/>
+          </a:ln>
+        </p:spPr>
+      </p:pic>
+      <p:pic>
+        <p:nvPicPr>
+          <p:cNvPr id="212" name="Google Shape;212;p21"/>
           <p:cNvPicPr preferRelativeResize="0"/>
           <p:nvPr/>
         </p:nvPicPr>
@@ -16455,7 +16513,7 @@
       </p:pic>
       <p:sp>
         <p:nvSpPr>
-          <p:cNvPr id="212" name="Google Shape;212;p21"/>
+          <p:cNvPr id="213" name="Google Shape;213;p21"/>
           <p:cNvSpPr txBox="1"/>
           <p:nvPr/>
         </p:nvSpPr>
@@ -16513,7 +16571,7 @@
       </p:sp>
       <p:sp>
         <p:nvSpPr>
-          <p:cNvPr id="213" name="Google Shape;213;p21"/>
+          <p:cNvPr id="214" name="Google Shape;214;p21"/>
           <p:cNvSpPr txBox="1"/>
           <p:nvPr>
             <p:ph idx="4294967295" type="body"/>
@@ -16655,7 +16713,7 @@
       </p:sp>
       <p:pic>
         <p:nvPicPr>
-          <p:cNvPr id="214" name="Google Shape;214;p21"/>
+          <p:cNvPr id="215" name="Google Shape;215;p21"/>
           <p:cNvPicPr preferRelativeResize="0"/>
           <p:nvPr/>
         </p:nvPicPr>
@@ -16701,7 +16759,7 @@
     </p:bg>
     <p:spTree>
       <p:nvGrpSpPr>
-        <p:cNvPr id="218" name="Shape 218"/>
+        <p:cNvPr id="219" name="Shape 219"/>
         <p:cNvGrpSpPr/>
         <p:nvPr/>
       </p:nvGrpSpPr>
@@ -16713,34 +16771,6 @@
           <a:chExt cx="0" cy="0"/>
         </a:xfrm>
       </p:grpSpPr>
-      <p:pic>
-        <p:nvPicPr>
-          <p:cNvPr id="219" name="Google Shape;219;p22"/>
-          <p:cNvPicPr preferRelativeResize="0"/>
-          <p:nvPr/>
-        </p:nvPicPr>
-        <p:blipFill>
-          <a:blip r:embed="rId3">
-            <a:alphaModFix amt="50000"/>
-          </a:blip>
-          <a:stretch>
-            <a:fillRect/>
-          </a:stretch>
-        </p:blipFill>
-        <p:spPr>
-          <a:xfrm>
-            <a:off x="4861025" y="877613"/>
-            <a:ext cx="3388275" cy="3388275"/>
-          </a:xfrm>
-          <a:prstGeom prst="rect">
-            <a:avLst/>
-          </a:prstGeom>
-          <a:noFill/>
-          <a:ln>
-            <a:noFill/>
-          </a:ln>
-        </p:spPr>
-      </p:pic>
       <p:pic>
         <p:nvPicPr>
           <p:cNvPr id="220" name="Google Shape;220;p22"/>
@@ -16757,7 +16787,7 @@
         </p:blipFill>
         <p:spPr>
           <a:xfrm>
-            <a:off x="894700" y="877613"/>
+            <a:off x="4861025" y="877613"/>
             <a:ext cx="3388275" cy="3388275"/>
           </a:xfrm>
           <a:prstGeom prst="rect">
@@ -16772,6 +16802,34 @@
       <p:pic>
         <p:nvPicPr>
           <p:cNvPr id="221" name="Google Shape;221;p22"/>
+          <p:cNvPicPr preferRelativeResize="0"/>
+          <p:nvPr/>
+        </p:nvPicPr>
+        <p:blipFill>
+          <a:blip r:embed="rId3">
+            <a:alphaModFix amt="50000"/>
+          </a:blip>
+          <a:stretch>
+            <a:fillRect/>
+          </a:stretch>
+        </p:blipFill>
+        <p:spPr>
+          <a:xfrm>
+            <a:off x="894700" y="877613"/>
+            <a:ext cx="3388275" cy="3388275"/>
+          </a:xfrm>
+          <a:prstGeom prst="rect">
+            <a:avLst/>
+          </a:prstGeom>
+          <a:noFill/>
+          <a:ln>
+            <a:noFill/>
+          </a:ln>
+        </p:spPr>
+      </p:pic>
+      <p:pic>
+        <p:nvPicPr>
+          <p:cNvPr id="222" name="Google Shape;222;p22"/>
           <p:cNvPicPr preferRelativeResize="0"/>
           <p:nvPr/>
         </p:nvPicPr>
@@ -16799,7 +16857,7 @@
       </p:pic>
       <p:sp>
         <p:nvSpPr>
-          <p:cNvPr id="222" name="Google Shape;222;p22"/>
+          <p:cNvPr id="223" name="Google Shape;223;p22"/>
           <p:cNvSpPr txBox="1"/>
           <p:nvPr/>
         </p:nvSpPr>
@@ -16857,7 +16915,7 @@
       </p:sp>
       <p:sp>
         <p:nvSpPr>
-          <p:cNvPr id="223" name="Google Shape;223;p22"/>
+          <p:cNvPr id="224" name="Google Shape;224;p22"/>
           <p:cNvSpPr txBox="1"/>
           <p:nvPr>
             <p:ph idx="4294967295" type="body"/>
@@ -16999,7 +17057,7 @@
       </p:sp>
       <p:pic>
         <p:nvPicPr>
-          <p:cNvPr id="224" name="Google Shape;224;p22"/>
+          <p:cNvPr id="225" name="Google Shape;225;p22"/>
           <p:cNvPicPr preferRelativeResize="0"/>
           <p:nvPr/>
         </p:nvPicPr>
@@ -17045,7 +17103,7 @@
     </p:bg>
     <p:spTree>
       <p:nvGrpSpPr>
-        <p:cNvPr id="228" name="Shape 228"/>
+        <p:cNvPr id="229" name="Shape 229"/>
         <p:cNvGrpSpPr/>
         <p:nvPr/>
       </p:nvGrpSpPr>
@@ -17057,34 +17115,6 @@
           <a:chExt cx="0" cy="0"/>
         </a:xfrm>
       </p:grpSpPr>
-      <p:pic>
-        <p:nvPicPr>
-          <p:cNvPr id="229" name="Google Shape;229;p23"/>
-          <p:cNvPicPr preferRelativeResize="0"/>
-          <p:nvPr/>
-        </p:nvPicPr>
-        <p:blipFill>
-          <a:blip r:embed="rId3">
-            <a:alphaModFix amt="50000"/>
-          </a:blip>
-          <a:stretch>
-            <a:fillRect/>
-          </a:stretch>
-        </p:blipFill>
-        <p:spPr>
-          <a:xfrm>
-            <a:off x="4629775" y="667691"/>
-            <a:ext cx="3808150" cy="3808125"/>
-          </a:xfrm>
-          <a:prstGeom prst="rect">
-            <a:avLst/>
-          </a:prstGeom>
-          <a:noFill/>
-          <a:ln>
-            <a:noFill/>
-          </a:ln>
-        </p:spPr>
-      </p:pic>
       <p:pic>
         <p:nvPicPr>
           <p:cNvPr id="230" name="Google Shape;230;p23"/>
@@ -17101,7 +17131,7 @@
         </p:blipFill>
         <p:spPr>
           <a:xfrm>
-            <a:off x="685325" y="667691"/>
+            <a:off x="4629775" y="667691"/>
             <a:ext cx="3808150" cy="3808125"/>
           </a:xfrm>
           <a:prstGeom prst="rect">
@@ -17116,6 +17146,34 @@
       <p:pic>
         <p:nvPicPr>
           <p:cNvPr id="231" name="Google Shape;231;p23"/>
+          <p:cNvPicPr preferRelativeResize="0"/>
+          <p:nvPr/>
+        </p:nvPicPr>
+        <p:blipFill>
+          <a:blip r:embed="rId3">
+            <a:alphaModFix amt="50000"/>
+          </a:blip>
+          <a:stretch>
+            <a:fillRect/>
+          </a:stretch>
+        </p:blipFill>
+        <p:spPr>
+          <a:xfrm>
+            <a:off x="685325" y="667691"/>
+            <a:ext cx="3808150" cy="3808125"/>
+          </a:xfrm>
+          <a:prstGeom prst="rect">
+            <a:avLst/>
+          </a:prstGeom>
+          <a:noFill/>
+          <a:ln>
+            <a:noFill/>
+          </a:ln>
+        </p:spPr>
+      </p:pic>
+      <p:pic>
+        <p:nvPicPr>
+          <p:cNvPr id="232" name="Google Shape;232;p23"/>
           <p:cNvPicPr preferRelativeResize="0"/>
           <p:nvPr/>
         </p:nvPicPr>
@@ -17143,7 +17201,7 @@
       </p:pic>
       <p:sp>
         <p:nvSpPr>
-          <p:cNvPr id="232" name="Google Shape;232;p23"/>
+          <p:cNvPr id="233" name="Google Shape;233;p23"/>
           <p:cNvSpPr txBox="1"/>
           <p:nvPr/>
         </p:nvSpPr>
@@ -17201,7 +17259,7 @@
       </p:sp>
       <p:sp>
         <p:nvSpPr>
-          <p:cNvPr id="233" name="Google Shape;233;p23"/>
+          <p:cNvPr id="234" name="Google Shape;234;p23"/>
           <p:cNvSpPr txBox="1"/>
           <p:nvPr>
             <p:ph idx="4294967295" type="body"/>
@@ -17343,7 +17401,7 @@
       </p:sp>
       <p:pic>
         <p:nvPicPr>
-          <p:cNvPr id="234" name="Google Shape;234;p23"/>
+          <p:cNvPr id="235" name="Google Shape;235;p23"/>
           <p:cNvPicPr preferRelativeResize="0"/>
           <p:nvPr/>
         </p:nvPicPr>
@@ -17378,6 +17436,285 @@
 </file>
 
 <file path=ppt/theme/theme1.xml><?xml version="1.0" encoding="utf-8"?>
+<a:theme xmlns:a="http://schemas.openxmlformats.org/drawingml/2006/main" xmlns:r="http://schemas.openxmlformats.org/officeDocument/2006/relationships">
+  <a:themeElements>
+    <a:clrScheme name="Default">
+      <a:dk1>
+        <a:srgbClr val="000000"/>
+      </a:dk1>
+      <a:lt1>
+        <a:srgbClr val="FFFFFF"/>
+      </a:lt1>
+      <a:dk2>
+        <a:srgbClr val="158158"/>
+      </a:dk2>
+      <a:lt2>
+        <a:srgbClr val="F3F3F3"/>
+      </a:lt2>
+      <a:accent1>
+        <a:srgbClr val="058DC7"/>
+      </a:accent1>
+      <a:accent2>
+        <a:srgbClr val="50B432"/>
+      </a:accent2>
+      <a:accent3>
+        <a:srgbClr val="ED561B"/>
+      </a:accent3>
+      <a:accent4>
+        <a:srgbClr val="EDEF00"/>
+      </a:accent4>
+      <a:accent5>
+        <a:srgbClr val="24CBE5"/>
+      </a:accent5>
+      <a:accent6>
+        <a:srgbClr val="64E572"/>
+      </a:accent6>
+      <a:hlink>
+        <a:srgbClr val="2200CC"/>
+      </a:hlink>
+      <a:folHlink>
+        <a:srgbClr val="551A8B"/>
+      </a:folHlink>
+    </a:clrScheme>
+    <a:fontScheme name="Office">
+      <a:majorFont>
+        <a:latin typeface="Arial"/>
+        <a:ea typeface=""/>
+        <a:cs typeface=""/>
+        <a:font script="Jpan" typeface="ＭＳ Ｐゴシック"/>
+        <a:font script="Hang" typeface="맑은 고딕"/>
+        <a:font script="Hans" typeface="宋体"/>
+        <a:font script="Hant" typeface="新細明體"/>
+        <a:font script="Arab" typeface="Times New Roman"/>
+        <a:font script="Hebr" typeface="Times New Roman"/>
+        <a:font script="Thai" typeface="Angsana New"/>
+        <a:font script="Ethi" typeface="Nyala"/>
+        <a:font script="Beng" typeface="Vrinda"/>
+        <a:font script="Gujr" typeface="Shruti"/>
+        <a:font script="Khmr" typeface="MoolBoran"/>
+        <a:font script="Knda" typeface="Tunga"/>
+        <a:font script="Guru" typeface="Raavi"/>
+        <a:font script="Cans" typeface="Euphemia"/>
+        <a:font script="Cher" typeface="Plantagenet Cherokee"/>
+        <a:font script="Yiii" typeface="Microsoft Yi Baiti"/>
+        <a:font script="Tibt" typeface="Microsoft Himalaya"/>
+        <a:font script="Thaa" typeface="MV Boli"/>
+        <a:font script="Deva" typeface="Mangal"/>
+        <a:font script="Telu" typeface="Gautami"/>
+        <a:font script="Taml" typeface="Latha"/>
+        <a:font script="Syrc" typeface="Estrangelo Edessa"/>
+        <a:font script="Orya" typeface="Kalinga"/>
+        <a:font script="Mlym" typeface="Kartika"/>
+        <a:font script="Laoo" typeface="DokChampa"/>
+        <a:font script="Sinh" typeface="Iskoola Pota"/>
+        <a:font script="Mong" typeface="Mongolian Baiti"/>
+        <a:font script="Viet" typeface="Times New Roman"/>
+        <a:font script="Uigh" typeface="Microsoft Uighur"/>
+        <a:font script="Geor" typeface="Sylfaen"/>
+      </a:majorFont>
+      <a:minorFont>
+        <a:latin typeface="Arial"/>
+        <a:ea typeface=""/>
+        <a:cs typeface=""/>
+        <a:font script="Jpan" typeface="ＭＳ Ｐゴシック"/>
+        <a:font script="Hang" typeface="맑은 고딕"/>
+        <a:font script="Hans" typeface="宋体"/>
+        <a:font script="Hant" typeface="新細明體"/>
+        <a:font script="Arab" typeface="Arial"/>
+        <a:font script="Hebr" typeface="Arial"/>
+        <a:font script="Thai" typeface="Cordia New"/>
+        <a:font script="Ethi" typeface="Nyala"/>
+        <a:font script="Beng" typeface="Vrinda"/>
+        <a:font script="Gujr" typeface="Shruti"/>
+        <a:font script="Khmr" typeface="DaunPenh"/>
+        <a:font script="Knda" typeface="Tunga"/>
+        <a:font script="Guru" typeface="Raavi"/>
+        <a:font script="Cans" typeface="Euphemia"/>
+        <a:font script="Cher" typeface="Plantagenet Cherokee"/>
+        <a:font script="Yiii" typeface="Microsoft Yi Baiti"/>
+        <a:font script="Tibt" typeface="Microsoft Himalaya"/>
+        <a:font script="Thaa" typeface="MV Boli"/>
+        <a:font script="Deva" typeface="Mangal"/>
+        <a:font script="Telu" typeface="Gautami"/>
+        <a:font script="Taml" typeface="Latha"/>
+        <a:font script="Syrc" typeface="Estrangelo Edessa"/>
+        <a:font script="Orya" typeface="Kalinga"/>
+        <a:font script="Mlym" typeface="Kartika"/>
+        <a:font script="Laoo" typeface="DokChampa"/>
+        <a:font script="Sinh" typeface="Iskoola Pota"/>
+        <a:font script="Mong" typeface="Mongolian Baiti"/>
+        <a:font script="Viet" typeface="Arial"/>
+        <a:font script="Uigh" typeface="Microsoft Uighur"/>
+        <a:font script="Geor" typeface="Sylfaen"/>
+      </a:minorFont>
+    </a:fontScheme>
+    <a:fmtScheme name="Office">
+      <a:fillStyleLst>
+        <a:solidFill>
+          <a:schemeClr val="phClr"/>
+        </a:solidFill>
+        <a:gradFill rotWithShape="1">
+          <a:gsLst>
+            <a:gs pos="0">
+              <a:schemeClr val="phClr">
+                <a:tint val="50000"/>
+                <a:satMod val="300000"/>
+              </a:schemeClr>
+            </a:gs>
+            <a:gs pos="35000">
+              <a:schemeClr val="phClr">
+                <a:tint val="37000"/>
+                <a:satMod val="300000"/>
+              </a:schemeClr>
+            </a:gs>
+            <a:gs pos="100000">
+              <a:schemeClr val="phClr">
+                <a:tint val="15000"/>
+                <a:satMod val="350000"/>
+              </a:schemeClr>
+            </a:gs>
+          </a:gsLst>
+          <a:lin ang="16200000" scaled="1"/>
+        </a:gradFill>
+        <a:gradFill rotWithShape="1">
+          <a:gsLst>
+            <a:gs pos="0">
+              <a:schemeClr val="phClr">
+                <a:tint val="100000"/>
+                <a:shade val="100000"/>
+                <a:satMod val="130000"/>
+              </a:schemeClr>
+            </a:gs>
+            <a:gs pos="100000">
+              <a:schemeClr val="phClr">
+                <a:tint val="50000"/>
+                <a:shade val="100000"/>
+                <a:satMod val="350000"/>
+              </a:schemeClr>
+            </a:gs>
+          </a:gsLst>
+          <a:lin ang="16200000" scaled="0"/>
+        </a:gradFill>
+      </a:fillStyleLst>
+      <a:lnStyleLst>
+        <a:ln w="9525" cap="flat" cmpd="sng" algn="ctr">
+          <a:solidFill>
+            <a:schemeClr val="phClr">
+              <a:shade val="95000"/>
+              <a:satMod val="105000"/>
+            </a:schemeClr>
+          </a:solidFill>
+          <a:prstDash val="solid"/>
+        </a:ln>
+        <a:ln w="25400" cap="flat" cmpd="sng" algn="ctr">
+          <a:solidFill>
+            <a:schemeClr val="phClr"/>
+          </a:solidFill>
+          <a:prstDash val="solid"/>
+        </a:ln>
+        <a:ln w="38100" cap="flat" cmpd="sng" algn="ctr">
+          <a:solidFill>
+            <a:schemeClr val="phClr"/>
+          </a:solidFill>
+          <a:prstDash val="solid"/>
+        </a:ln>
+      </a:lnStyleLst>
+      <a:effectStyleLst>
+        <a:effectStyle>
+          <a:effectLst>
+            <a:outerShdw blurRad="40000" dist="20000" dir="5400000" rotWithShape="0">
+              <a:srgbClr val="000000">
+                <a:alpha val="38000"/>
+              </a:srgbClr>
+            </a:outerShdw>
+          </a:effectLst>
+        </a:effectStyle>
+        <a:effectStyle>
+          <a:effectLst>
+            <a:outerShdw blurRad="40000" dist="23000" dir="5400000" rotWithShape="0">
+              <a:srgbClr val="000000">
+                <a:alpha val="35000"/>
+              </a:srgbClr>
+            </a:outerShdw>
+          </a:effectLst>
+        </a:effectStyle>
+        <a:effectStyle>
+          <a:effectLst>
+            <a:outerShdw blurRad="40000" dist="23000" dir="5400000" rotWithShape="0">
+              <a:srgbClr val="000000">
+                <a:alpha val="35000"/>
+              </a:srgbClr>
+            </a:outerShdw>
+          </a:effectLst>
+          <a:scene3d>
+            <a:camera prst="orthographicFront">
+              <a:rot lat="0" lon="0" rev="0"/>
+            </a:camera>
+            <a:lightRig rig="threePt" dir="t">
+              <a:rot lat="0" lon="0" rev="1200000"/>
+            </a:lightRig>
+          </a:scene3d>
+          <a:sp3d>
+            <a:bevelT w="63500" h="25400"/>
+          </a:sp3d>
+        </a:effectStyle>
+      </a:effectStyleLst>
+      <a:bgFillStyleLst>
+        <a:solidFill>
+          <a:schemeClr val="phClr"/>
+        </a:solidFill>
+        <a:gradFill rotWithShape="1">
+          <a:gsLst>
+            <a:gs pos="0">
+              <a:schemeClr val="phClr">
+                <a:tint val="40000"/>
+                <a:satMod val="350000"/>
+              </a:schemeClr>
+            </a:gs>
+            <a:gs pos="40000">
+              <a:schemeClr val="phClr">
+                <a:tint val="45000"/>
+                <a:shade val="99000"/>
+                <a:satMod val="350000"/>
+              </a:schemeClr>
+            </a:gs>
+            <a:gs pos="100000">
+              <a:schemeClr val="phClr">
+                <a:shade val="20000"/>
+                <a:satMod val="255000"/>
+              </a:schemeClr>
+            </a:gs>
+          </a:gsLst>
+          <a:path path="circle">
+            <a:fillToRect l="50000" t="-80000" r="50000" b="180000"/>
+          </a:path>
+        </a:gradFill>
+        <a:gradFill rotWithShape="1">
+          <a:gsLst>
+            <a:gs pos="0">
+              <a:schemeClr val="phClr">
+                <a:tint val="80000"/>
+                <a:satMod val="300000"/>
+              </a:schemeClr>
+            </a:gs>
+            <a:gs pos="100000">
+              <a:schemeClr val="phClr">
+                <a:shade val="30000"/>
+                <a:satMod val="200000"/>
+              </a:schemeClr>
+            </a:gs>
+          </a:gsLst>
+          <a:path path="circle">
+            <a:fillToRect l="50000" t="50000" r="50000" b="50000"/>
+          </a:path>
+        </a:gradFill>
+      </a:bgFillStyleLst>
+    </a:fmtScheme>
+  </a:themeElements>
+</a:theme>
+</file>
+
+<file path=ppt/theme/theme2.xml><?xml version="1.0" encoding="utf-8"?>
 <a:theme xmlns:a="http://schemas.openxmlformats.org/drawingml/2006/main" xmlns:r="http://schemas.openxmlformats.org/officeDocument/2006/relationships" name="Swiss">
   <a:themeElements>
     <a:clrScheme name="Swiss">
@@ -17654,283 +17991,4 @@
     </a:fmtScheme>
   </a:themeElements>
 </a:theme>
-</file>
-
-<file path=ppt/theme/theme2.xml><?xml version="1.0" encoding="utf-8"?>
-<a:theme xmlns:a="http://schemas.openxmlformats.org/drawingml/2006/main" xmlns:r="http://schemas.openxmlformats.org/officeDocument/2006/relationships">
-  <a:themeElements>
-    <a:clrScheme name="Default">
-      <a:dk1>
-        <a:srgbClr val="000000"/>
-      </a:dk1>
-      <a:lt1>
-        <a:srgbClr val="FFFFFF"/>
-      </a:lt1>
-      <a:dk2>
-        <a:srgbClr val="158158"/>
-      </a:dk2>
-      <a:lt2>
-        <a:srgbClr val="F3F3F3"/>
-      </a:lt2>
-      <a:accent1>
-        <a:srgbClr val="058DC7"/>
-      </a:accent1>
-      <a:accent2>
-        <a:srgbClr val="50B432"/>
-      </a:accent2>
-      <a:accent3>
-        <a:srgbClr val="ED561B"/>
-      </a:accent3>
-      <a:accent4>
-        <a:srgbClr val="EDEF00"/>
-      </a:accent4>
-      <a:accent5>
-        <a:srgbClr val="24CBE5"/>
-      </a:accent5>
-      <a:accent6>
-        <a:srgbClr val="64E572"/>
-      </a:accent6>
-      <a:hlink>
-        <a:srgbClr val="2200CC"/>
-      </a:hlink>
-      <a:folHlink>
-        <a:srgbClr val="551A8B"/>
-      </a:folHlink>
-    </a:clrScheme>
-    <a:fontScheme name="Office">
-      <a:majorFont>
-        <a:latin typeface="Arial"/>
-        <a:ea typeface=""/>
-        <a:cs typeface=""/>
-        <a:font script="Jpan" typeface="ＭＳ Ｐゴシック"/>
-        <a:font script="Hang" typeface="맑은 고딕"/>
-        <a:font script="Hans" typeface="宋体"/>
-        <a:font script="Hant" typeface="新細明體"/>
-        <a:font script="Arab" typeface="Times New Roman"/>
-        <a:font script="Hebr" typeface="Times New Roman"/>
-        <a:font script="Thai" typeface="Angsana New"/>
-        <a:font script="Ethi" typeface="Nyala"/>
-        <a:font script="Beng" typeface="Vrinda"/>
-        <a:font script="Gujr" typeface="Shruti"/>
-        <a:font script="Khmr" typeface="MoolBoran"/>
-        <a:font script="Knda" typeface="Tunga"/>
-        <a:font script="Guru" typeface="Raavi"/>
-        <a:font script="Cans" typeface="Euphemia"/>
-        <a:font script="Cher" typeface="Plantagenet Cherokee"/>
-        <a:font script="Yiii" typeface="Microsoft Yi Baiti"/>
-        <a:font script="Tibt" typeface="Microsoft Himalaya"/>
-        <a:font script="Thaa" typeface="MV Boli"/>
-        <a:font script="Deva" typeface="Mangal"/>
-        <a:font script="Telu" typeface="Gautami"/>
-        <a:font script="Taml" typeface="Latha"/>
-        <a:font script="Syrc" typeface="Estrangelo Edessa"/>
-        <a:font script="Orya" typeface="Kalinga"/>
-        <a:font script="Mlym" typeface="Kartika"/>
-        <a:font script="Laoo" typeface="DokChampa"/>
-        <a:font script="Sinh" typeface="Iskoola Pota"/>
-        <a:font script="Mong" typeface="Mongolian Baiti"/>
-        <a:font script="Viet" typeface="Times New Roman"/>
-        <a:font script="Uigh" typeface="Microsoft Uighur"/>
-        <a:font script="Geor" typeface="Sylfaen"/>
-      </a:majorFont>
-      <a:minorFont>
-        <a:latin typeface="Arial"/>
-        <a:ea typeface=""/>
-        <a:cs typeface=""/>
-        <a:font script="Jpan" typeface="ＭＳ Ｐゴシック"/>
-        <a:font script="Hang" typeface="맑은 고딕"/>
-        <a:font script="Hans" typeface="宋体"/>
-        <a:font script="Hant" typeface="新細明體"/>
-        <a:font script="Arab" typeface="Arial"/>
-        <a:font script="Hebr" typeface="Arial"/>
-        <a:font script="Thai" typeface="Cordia New"/>
-        <a:font script="Ethi" typeface="Nyala"/>
-        <a:font script="Beng" typeface="Vrinda"/>
-        <a:font script="Gujr" typeface="Shruti"/>
-        <a:font script="Khmr" typeface="DaunPenh"/>
-        <a:font script="Knda" typeface="Tunga"/>
-        <a:font script="Guru" typeface="Raavi"/>
-        <a:font script="Cans" typeface="Euphemia"/>
-        <a:font script="Cher" typeface="Plantagenet Cherokee"/>
-        <a:font script="Yiii" typeface="Microsoft Yi Baiti"/>
-        <a:font script="Tibt" typeface="Microsoft Himalaya"/>
-        <a:font script="Thaa" typeface="MV Boli"/>
-        <a:font script="Deva" typeface="Mangal"/>
-        <a:font script="Telu" typeface="Gautami"/>
-        <a:font script="Taml" typeface="Latha"/>
-        <a:font script="Syrc" typeface="Estrangelo Edessa"/>
-        <a:font script="Orya" typeface="Kalinga"/>
-        <a:font script="Mlym" typeface="Kartika"/>
-        <a:font script="Laoo" typeface="DokChampa"/>
-        <a:font script="Sinh" typeface="Iskoola Pota"/>
-        <a:font script="Mong" typeface="Mongolian Baiti"/>
-        <a:font script="Viet" typeface="Arial"/>
-        <a:font script="Uigh" typeface="Microsoft Uighur"/>
-        <a:font script="Geor" typeface="Sylfaen"/>
-      </a:minorFont>
-    </a:fontScheme>
-    <a:fmtScheme name="Office">
-      <a:fillStyleLst>
-        <a:solidFill>
-          <a:schemeClr val="phClr"/>
-        </a:solidFill>
-        <a:gradFill rotWithShape="1">
-          <a:gsLst>
-            <a:gs pos="0">
-              <a:schemeClr val="phClr">
-                <a:tint val="50000"/>
-                <a:satMod val="300000"/>
-              </a:schemeClr>
-            </a:gs>
-            <a:gs pos="35000">
-              <a:schemeClr val="phClr">
-                <a:tint val="37000"/>
-                <a:satMod val="300000"/>
-              </a:schemeClr>
-            </a:gs>
-            <a:gs pos="100000">
-              <a:schemeClr val="phClr">
-                <a:tint val="15000"/>
-                <a:satMod val="350000"/>
-              </a:schemeClr>
-            </a:gs>
-          </a:gsLst>
-          <a:lin ang="16200000" scaled="1"/>
-        </a:gradFill>
-        <a:gradFill rotWithShape="1">
-          <a:gsLst>
-            <a:gs pos="0">
-              <a:schemeClr val="phClr">
-                <a:tint val="100000"/>
-                <a:shade val="100000"/>
-                <a:satMod val="130000"/>
-              </a:schemeClr>
-            </a:gs>
-            <a:gs pos="100000">
-              <a:schemeClr val="phClr">
-                <a:tint val="50000"/>
-                <a:shade val="100000"/>
-                <a:satMod val="350000"/>
-              </a:schemeClr>
-            </a:gs>
-          </a:gsLst>
-          <a:lin ang="16200000" scaled="0"/>
-        </a:gradFill>
-      </a:fillStyleLst>
-      <a:lnStyleLst>
-        <a:ln w="9525" cap="flat" cmpd="sng" algn="ctr">
-          <a:solidFill>
-            <a:schemeClr val="phClr">
-              <a:shade val="95000"/>
-              <a:satMod val="105000"/>
-            </a:schemeClr>
-          </a:solidFill>
-          <a:prstDash val="solid"/>
-        </a:ln>
-        <a:ln w="25400" cap="flat" cmpd="sng" algn="ctr">
-          <a:solidFill>
-            <a:schemeClr val="phClr"/>
-          </a:solidFill>
-          <a:prstDash val="solid"/>
-        </a:ln>
-        <a:ln w="38100" cap="flat" cmpd="sng" algn="ctr">
-          <a:solidFill>
-            <a:schemeClr val="phClr"/>
-          </a:solidFill>
-          <a:prstDash val="solid"/>
-        </a:ln>
-      </a:lnStyleLst>
-      <a:effectStyleLst>
-        <a:effectStyle>
-          <a:effectLst>
-            <a:outerShdw blurRad="40000" dist="20000" dir="5400000" rotWithShape="0">
-              <a:srgbClr val="000000">
-                <a:alpha val="38000"/>
-              </a:srgbClr>
-            </a:outerShdw>
-          </a:effectLst>
-        </a:effectStyle>
-        <a:effectStyle>
-          <a:effectLst>
-            <a:outerShdw blurRad="40000" dist="23000" dir="5400000" rotWithShape="0">
-              <a:srgbClr val="000000">
-                <a:alpha val="35000"/>
-              </a:srgbClr>
-            </a:outerShdw>
-          </a:effectLst>
-        </a:effectStyle>
-        <a:effectStyle>
-          <a:effectLst>
-            <a:outerShdw blurRad="40000" dist="23000" dir="5400000" rotWithShape="0">
-              <a:srgbClr val="000000">
-                <a:alpha val="35000"/>
-              </a:srgbClr>
-            </a:outerShdw>
-          </a:effectLst>
-          <a:scene3d>
-            <a:camera prst="orthographicFront">
-              <a:rot lat="0" lon="0" rev="0"/>
-            </a:camera>
-            <a:lightRig rig="threePt" dir="t">
-              <a:rot lat="0" lon="0" rev="1200000"/>
-            </a:lightRig>
-          </a:scene3d>
-          <a:sp3d>
-            <a:bevelT w="63500" h="25400"/>
-          </a:sp3d>
-        </a:effectStyle>
-      </a:effectStyleLst>
-      <a:bgFillStyleLst>
-        <a:solidFill>
-          <a:schemeClr val="phClr"/>
-        </a:solidFill>
-        <a:gradFill rotWithShape="1">
-          <a:gsLst>
-            <a:gs pos="0">
-              <a:schemeClr val="phClr">
-                <a:tint val="40000"/>
-                <a:satMod val="350000"/>
-              </a:schemeClr>
-            </a:gs>
-            <a:gs pos="40000">
-              <a:schemeClr val="phClr">
-                <a:tint val="45000"/>
-                <a:shade val="99000"/>
-                <a:satMod val="350000"/>
-              </a:schemeClr>
-            </a:gs>
-            <a:gs pos="100000">
-              <a:schemeClr val="phClr">
-                <a:shade val="20000"/>
-                <a:satMod val="255000"/>
-              </a:schemeClr>
-            </a:gs>
-          </a:gsLst>
-          <a:path path="circle">
-            <a:fillToRect l="50000" t="-80000" r="50000" b="180000"/>
-          </a:path>
-        </a:gradFill>
-        <a:gradFill rotWithShape="1">
-          <a:gsLst>
-            <a:gs pos="0">
-              <a:schemeClr val="phClr">
-                <a:tint val="80000"/>
-                <a:satMod val="300000"/>
-              </a:schemeClr>
-            </a:gs>
-            <a:gs pos="100000">
-              <a:schemeClr val="phClr">
-                <a:shade val="30000"/>
-                <a:satMod val="200000"/>
-              </a:schemeClr>
-            </a:gs>
-          </a:gsLst>
-          <a:path path="circle">
-            <a:fillToRect l="50000" t="50000" r="50000" b="50000"/>
-          </a:path>
-        </a:gradFill>
-      </a:bgFillStyleLst>
-    </a:fmtScheme>
-  </a:themeElements>
-</a:theme>
 </file>
</xml_diff>